<commit_message>
Catch-up pack: CURRENT SNAPSHOT in STATUS.md, entry-point files route AIs to it
Any fresh clone now self-orients: RULES → HANDOFF+Amendments → STATUS's
CURRENT SNAPSHOT (exact project state, deliverables in flight, ranked next
steps) → ONBOARDING (incl. team test accounts — passwords with the owner,
never in-repo) → DECISIONS D-001..D-015. Owner-verified on device: email
sign-in, invitation claim, not-invited gate, live assistant answers.

Co-Authored-By: Claude Fable 5 <noreply@anthropic.com>
</commit_message>
<xml_diff>
--- a/pitch/afia-pitch.pptx
+++ b/pitch/afia-pitch.pptx
@@ -4,6 +4,9 @@
   <p:sldMasterIdLst>
     <p:sldMasterId id="2147483648" r:id="rId1"/>
   </p:sldMasterIdLst>
+  <p:notesMasterIdLst>
+    <p:notesMasterId r:id="rId23"/>
+  </p:notesMasterIdLst>
   <p:sldIdLst>
     <p:sldId id="256" r:id="rId2"/>
     <p:sldId id="257" r:id="rId3"/>
@@ -27,9 +30,6 @@
     <p:sldId id="275" r:id="rId21"/>
     <p:sldId id="276" r:id="rId22"/>
   </p:sldIdLst>
-  <p:notesMasterIdLst>
-    <p:notesMasterId r:id="rId23"/>
-  </p:notesMasterIdLst>
   <p:sldSz cx="12192000" cy="6858000"/>
   <p:notesSz cx="6858000" cy="12192000"/>
   <p:defaultTextStyle>
@@ -124,6 +124,11 @@
       </a:defRPr>
     </a:lvl9pPr>
   </p:defaultTextStyle>
+  <p:extLst>
+    <p:ext uri="{EFAFB233-063F-42B5-8137-9DF3F51BA10A}">
+      <p15:sldGuideLst xmlns:p15="http://schemas.microsoft.com/office/powerpoint/2012/main"/>
+    </p:ext>
+  </p:extLst>
 </p:presentation>
 </file>
 
@@ -149,234 +154,10 @@
           <a:chExt cx="0" cy="0"/>
         </a:xfrm>
       </p:grpSpPr>
-      <p:sp>
-        <p:nvSpPr>
-          <p:cNvPr id="2" name="Header Placeholder 1"/>
-          <p:cNvSpPr>
-            <a:spLocks noGrp="1"/>
-          </p:cNvSpPr>
-          <p:nvPr>
-            <p:ph type="hdr" sz="quarter"/>
-          </p:nvPr>
-        </p:nvSpPr>
-        <p:spPr>
-          <a:xfrm>
-            <a:off x="0" y="0"/>
-            <a:ext cx="2971800" cy="458788"/>
-          </a:xfrm>
-          <a:prstGeom prst="rect">
-            <a:avLst/>
-          </a:prstGeom>
-        </p:spPr>
-        <p:txBody>
-          <a:bodyPr vert="horz" lIns="91440" tIns="45720" rIns="91440" bIns="45720" rtlCol="0"/>
-          <a:lstStyle>
-            <a:lvl1pPr algn="l">
-              <a:defRPr sz="1200"/>
-            </a:lvl1pPr>
-          </a:lstStyle>
-          <a:p>
-            <a:endParaRPr lang="en-US"/>
-          </a:p>
-        </p:txBody>
-      </p:sp>
-      <p:sp>
-        <p:nvSpPr>
-          <p:cNvPr id="3" name="Date Placeholder 2"/>
-          <p:cNvSpPr>
-            <a:spLocks noGrp="1"/>
-          </p:cNvSpPr>
-          <p:nvPr>
-            <p:ph type="dt" idx="1"/>
-          </p:nvPr>
-        </p:nvSpPr>
-        <p:spPr>
-          <a:xfrm>
-            <a:off x="3884613" y="0"/>
-            <a:ext cx="2971800" cy="458788"/>
-          </a:xfrm>
-          <a:prstGeom prst="rect">
-            <a:avLst/>
-          </a:prstGeom>
-        </p:spPr>
-        <p:txBody>
-          <a:bodyPr vert="horz" lIns="91440" tIns="45720" rIns="91440" bIns="45720" rtlCol="0"/>
-          <a:lstStyle>
-            <a:lvl1pPr algn="r">
-              <a:defRPr sz="1200"/>
-            </a:lvl1pPr>
-          </a:lstStyle>
-          <a:p>
-            <a:fld id="{5282F153-3F37-0F45-9E97-73ACFA13230C}" type="datetimeFigureOut">
-              <a:rPr lang="en-US"/>
-              <a:t>7/23/19</a:t>
-            </a:fld>
-            <a:endParaRPr lang="en-US"/>
-          </a:p>
-        </p:txBody>
-      </p:sp>
-      <p:sp>
-        <p:nvSpPr>
-          <p:cNvPr id="4" name="Slide Image Placeholder 3"/>
-          <p:cNvSpPr>
-            <a:spLocks noGrp="1" noRot="1" noChangeAspect="1"/>
-          </p:cNvSpPr>
-          <p:nvPr>
-            <p:ph type="sldImg" idx="2"/>
-          </p:nvPr>
-        </p:nvSpPr>
-        <p:spPr>
-          <a:xfrm>
-            <a:off x="685800" y="1143000"/>
-            <a:ext cx="5486400" cy="3086100"/>
-          </a:xfrm>
-          <a:prstGeom prst="rect">
-            <a:avLst/>
-          </a:prstGeom>
-          <a:noFill/>
-          <a:ln w="12700">
-            <a:solidFill>
-              <a:prstClr val="black"/>
-            </a:solidFill>
-          </a:ln>
-        </p:spPr>
-        <p:txBody>
-          <a:bodyPr vert="horz" lIns="91440" tIns="45720" rIns="91440" bIns="45720" rtlCol="0" anchor="ctr"/>
-          <a:lstStyle/>
-          <a:p>
-            <a:endParaRPr lang="en-US"/>
-          </a:p>
-        </p:txBody>
-      </p:sp>
-      <p:sp>
-        <p:nvSpPr>
-          <p:cNvPr id="5" name="Notes Placeholder 4"/>
-          <p:cNvSpPr>
-            <a:spLocks noGrp="1"/>
-          </p:cNvSpPr>
-          <p:nvPr>
-            <p:ph type="body" sz="quarter" idx="3"/>
-          </p:nvPr>
-        </p:nvSpPr>
-        <p:spPr>
-          <a:xfrm>
-            <a:off x="685800" y="4400550"/>
-            <a:ext cx="5486400" cy="3600450"/>
-          </a:xfrm>
-          <a:prstGeom prst="rect">
-            <a:avLst/>
-          </a:prstGeom>
-        </p:spPr>
-        <p:txBody>
-          <a:bodyPr vert="horz" lIns="91440" tIns="45720" rIns="91440" bIns="45720" rtlCol="0"/>
-          <a:lstStyle/>
-          <a:p>
-            <a:pPr lvl="0"/>
-            <a:r>
-              <a:rPr lang="en-US"/>
-              <a:t>Click to edit Master text styles</a:t>
-            </a:r>
-          </a:p>
-          <a:p>
-            <a:pPr lvl="1"/>
-            <a:r>
-              <a:rPr lang="en-US"/>
-              <a:t>Second level</a:t>
-            </a:r>
-          </a:p>
-          <a:p>
-            <a:pPr lvl="2"/>
-            <a:r>
-              <a:rPr lang="en-US"/>
-              <a:t>Third level</a:t>
-            </a:r>
-          </a:p>
-          <a:p>
-            <a:pPr lvl="3"/>
-            <a:r>
-              <a:rPr lang="en-US"/>
-              <a:t>Fourth level</a:t>
-            </a:r>
-          </a:p>
-          <a:p>
-            <a:pPr lvl="4"/>
-            <a:r>
-              <a:rPr lang="en-US"/>
-              <a:t>Fifth level</a:t>
-            </a:r>
-          </a:p>
-        </p:txBody>
-      </p:sp>
-      <p:sp>
-        <p:nvSpPr>
-          <p:cNvPr id="6" name="Footer Placeholder 5"/>
-          <p:cNvSpPr>
-            <a:spLocks noGrp="1"/>
-          </p:cNvSpPr>
-          <p:nvPr>
-            <p:ph type="ftr" sz="quarter" idx="4"/>
-          </p:nvPr>
-        </p:nvSpPr>
-        <p:spPr>
-          <a:xfrm>
-            <a:off x="0" y="8685213"/>
-            <a:ext cx="2971800" cy="458787"/>
-          </a:xfrm>
-          <a:prstGeom prst="rect">
-            <a:avLst/>
-          </a:prstGeom>
-        </p:spPr>
-        <p:txBody>
-          <a:bodyPr vert="horz" lIns="91440" tIns="45720" rIns="91440" bIns="45720" rtlCol="0" anchor="b"/>
-          <a:lstStyle>
-            <a:lvl1pPr algn="l">
-              <a:defRPr sz="1200"/>
-            </a:lvl1pPr>
-          </a:lstStyle>
-          <a:p>
-            <a:endParaRPr lang="en-US"/>
-          </a:p>
-        </p:txBody>
-      </p:sp>
-      <p:sp>
-        <p:nvSpPr>
-          <p:cNvPr id="7" name="Slide Number Placeholder 6"/>
-          <p:cNvSpPr>
-            <a:spLocks noGrp="1"/>
-          </p:cNvSpPr>
-          <p:nvPr>
-            <p:ph type="sldNum" sz="quarter" idx="5"/>
-          </p:nvPr>
-        </p:nvSpPr>
-        <p:spPr>
-          <a:xfrm>
-            <a:off x="3884613" y="8685213"/>
-            <a:ext cx="2971800" cy="458787"/>
-          </a:xfrm>
-          <a:prstGeom prst="rect">
-            <a:avLst/>
-          </a:prstGeom>
-        </p:spPr>
-        <p:txBody>
-          <a:bodyPr vert="horz" lIns="91440" tIns="45720" rIns="91440" bIns="45720" rtlCol="0" anchor="b"/>
-          <a:lstStyle>
-            <a:lvl1pPr algn="r">
-              <a:defRPr sz="1200"/>
-            </a:lvl1pPr>
-          </a:lstStyle>
-          <a:p>
-            <a:fld id="{CE5E9CC1-C706-0F49-92D6-E571CC5EEA8F}" type="slidenum">
-              <a:rPr lang="en-US"/>
-              <a:t>‹#›</a:t>
-            </a:fld>
-            <a:endParaRPr lang="en-US"/>
-          </a:p>
-        </p:txBody>
-      </p:sp>
     </p:spTree>
     <p:extLst>
       <p:ext uri="{BB962C8B-B14F-4D97-AF65-F5344CB8AC3E}">
-        <p14:creationId xmlns:p14="http://schemas.microsoft.com/office/powerpoint/2010/main" val="1024086991"/>
+        <p14:creationId xmlns:p14="http://schemas.microsoft.com/office/powerpoint/2010/main" val="2986741118"/>
       </p:ext>
     </p:extLst>
   </p:cSld>
@@ -525,7 +306,6 @@
               <a:t>الافتتاح (١٥ ثانية): "قبل أن أريكم شيئًا — كل ما ستشاهدونه اليوم يعمل الآن، منشور فعليًا، وخلفه ١١٤ اختبارًا آليًا ناجحًا. هذا ليس نموذجًا."
 س: هل هذا عرض تصوري؟ ج: لا — تطبيقان iOS جاهزان على TestFlight ولوحة تحكم منشورة على الويب وقاعدة بيانات حية.</a:t>
             </a:r>
-            <a:endParaRPr lang="en-US" dirty="0"/>
           </a:p>
         </p:txBody>
       </p:sp>
@@ -614,7 +394,6 @@
               <a:t>س: ماذا لو طلب منه الممرض ترتيب المرضى بالأخطر؟ ج: يرفض ويشرح: الترتيب بالحقائق فقط (وقت الانتظار، الاكتمال، حالة التوقيع) — ترتيب الخطورة حكم سريري والنظام لا يصدره بنيويًا: لا توجد أداة تحمل حقل خطورة أصلًا.
 س: أي نموذج؟ ج: Gemini Flash عبر Firebase AI Logic — بلا خادم وسيط، ومع بديل حتمي يعمل بلا إنترنت فلا يتعطل التطبيق أبدًا.</a:t>
             </a:r>
-            <a:endParaRPr lang="en-US" dirty="0"/>
           </a:p>
         </p:txBody>
       </p:sp>
@@ -703,7 +482,6 @@
               <a:t>س: لماذا قاعدتا بيانات؟ ج: فصل مقصود — السجلات السريرية في Firestore (منطقة الشرق الأوسط)، وبيانات التشغيل اللحظية (حضور/طلبات — لا محتوى سريري) في Realtime DB. لكل عبء أداته.
 س: هل الطلبات موثقة؟ ج: نعم، بحالة معلّق→مقبول→منجز لا يعدلها إلا طرفا الطلب.</a:t>
             </a:r>
-            <a:endParaRPr lang="en-US" dirty="0"/>
           </a:p>
         </p:txBody>
       </p:sp>
@@ -792,7 +570,6 @@
               <a:t>س: لماذا الحساب أولًا؟ ج: اختبرناه — البساطة والوضوح فازا؛ ومع ذلك الطوارئ لا تحتاج حسابًا أبدًا: الزر يعمل من شاشة الدخول نفسها وبلا إنترنت.
 س: ماذا يرى المريض بعد الإرسال؟ ج: بطاقة حالة صادقة + نص إلزامي: "لا أحد يراقب حالتك باستمرار — إذا ساءت اتصل…" — منتج أمين لا يبيع شعورًا زائفًا بالأمان.</a:t>
             </a:r>
-            <a:endParaRPr lang="en-US" dirty="0"/>
           </a:p>
         </p:txBody>
       </p:sp>
@@ -881,7 +658,6 @@
               <a:t>س: لماذا لا تقيسون أداء الممرض الفرد؟ ج: قرار مبدئي محفور: لا سرعة فردية، لا ترتيب، لا مقارنات — القياس الفردي يفسد الثقة ويشوه السلوك. كل الجودة مجمّعة على مستوى الجناح.
 س: هل اللوحة في المسار السريري؟ ج: لا — تراقب وتضبط فقط؛ ملف المريض يذهب للممرض مباشرة.</a:t>
             </a:r>
-            <a:endParaRPr lang="en-US" dirty="0"/>
           </a:p>
         </p:txBody>
       </p:sp>
@@ -969,7 +745,6 @@
               <a:rPr lang="en-US" dirty="0"/>
               <a:t>انتقال: "الآن الجزء الذي يجعل كل ما سبق غير قابل للكسر."</a:t>
             </a:r>
-            <a:endParaRPr lang="en-US" dirty="0"/>
           </a:p>
         </p:txBody>
       </p:sp>
@@ -1058,7 +833,6 @@
               <a:t>س: هل أنتم متكاملون مع Epic/Cerner اليوم؟ ج: بدقة: نحن FHIR-ready — نولّد سجلات DocumentReference صالحة بمعيار المستشفيات العالمي؛ التكامل الفعلي مع أي نظام = مُصدِّر واحد يُكتب في التجربة الميدانية. لا نبيعكم تكاملًا لم يحدث.
 س: أين البيانات؟ ج: السجلات السريرية في منطقة الشرق الأوسط (me-central2)، محكومة بقواعد وصول صارمة، وللمريض حق حذف بياناته.</a:t>
             </a:r>
-            <a:endParaRPr lang="en-US" dirty="0"/>
           </a:p>
         </p:txBody>
       </p:sp>
@@ -1148,7 +922,6 @@
 س: لماذا تقيدون الذكاء لهذه الدرجة؟ ج: لأن خط "الجهاز الطبي" التنظيمي يبدأ حيث يبدأ الحكم السريري الآلي. بالبقاء خلفه بنيويًا: نشر أسرع، ثقة أعلى، ومسؤولية واضحة — الإنسان المرخص هو من يحكم دائمًا.
 س: أي نموذج ولماذا؟ ج: Gemini Flash عبر Firebase AI Logic — درجة حرارة صفر، مخرجات ببنية مفروضة، ويتعلم تفضيلات الاستخدام (لا الطب).</a:t>
             </a:r>
-            <a:endParaRPr lang="en-US" dirty="0"/>
           </a:p>
         </p:txBody>
       </p:sp>
@@ -1237,7 +1010,6 @@
               <a:t>الصدق هنا سلاح وليس اعترافًا — لجنة فيها أطباء ستحترم فريقًا يعرف حدود نظامه.
 س: كم استغرق البناء؟ ج: جلسة تطوير مكثفة واحدة بمنهجية وكلاء ذكاء اصطناعي متوازين تحت حوكمة صارمة — والدليل: كل commit موثق وكل ميزة وراءها اختبار.</a:t>
             </a:r>
-            <a:endParaRPr lang="en-US" dirty="0"/>
           </a:p>
         </p:txBody>
       </p:sp>
@@ -1325,7 +1097,6 @@
               <a:rPr lang="en-US" dirty="0"/>
               <a:t>انتقال سريع — الجمهور ثم SWOT ثم الإغلاق.</a:t>
             </a:r>
-            <a:endParaRPr lang="en-US" dirty="0"/>
           </a:p>
         </p:txBody>
       </p:sp>
@@ -1414,7 +1185,6 @@
               <a:t>س: لماذا البحرين أولًا؟ ج: قاعدة بياناتنا أصلًا في المنطقة، أرقام الطوارئ مدمجة (٩٩٩/٤٤٤)، حجم سوق يسمح بتجربة سريعة مع وصول مباشر لصناع القرار — ثم التوسع الخليجي بنفس المنتج حرفيًا.
 س: النموذج الربحي؟ ج: اشتراك سنوي لكل سرير + رسوم تفعيل مؤسسية — يُسعَّر بعد قياس وفر الوقت في التجربة الأولى.</a:t>
             </a:r>
-            <a:endParaRPr lang="en-US" dirty="0"/>
           </a:p>
         </p:txBody>
       </p:sp>
@@ -1503,7 +1273,6 @@
               <a:t>لغة الجسد: بطء وثقل. هذه شريحة الشعور — لا أرقام.
 س: ما مصدر هذه المشكلة؟ ج: تسليم المناوبات موثق عالميًا كأحد أكثر لحظات الرعاية عرضة لفقدان المعلومات؛ حلولنا صُممت مع هذه اللحظة كنقطة الصفر.</a:t>
             </a:r>
-            <a:endParaRPr lang="en-US" dirty="0"/>
           </a:p>
         </p:txBody>
       </p:sp>
@@ -1591,7 +1360,6 @@
               <a:rPr lang="en-US" dirty="0"/>
               <a:t>س: أكبر تهديد؟ ج: التصنيف التنظيمي — ولهذا بالضبط بنينا الذكاء بلا أحكام سريرية وبقواعد حتمية قابلة للتدقيق: نبقى في الجانب الآمن من الخط بتصميمنا لا بحظنا.</a:t>
             </a:r>
-            <a:endParaRPr lang="en-US" dirty="0"/>
           </a:p>
         </p:txBody>
       </p:sp>
@@ -1682,7 +1450,6 @@
 س: ما الذي تحتاجونه للفوز بعد اليوم؟ ج: جناح تجريبي واحد وشريك حكومي — كل شيء تقني جاهز.
 س: لماذا أنتم؟ ج: لأننا الوحيدون الذين جاؤوا بمنتج محكوم بقواعد سلامة قابلة للتدقيق — لا بعرض شرائح.</a:t>
             </a:r>
-            <a:endParaRPr lang="en-US" dirty="0"/>
           </a:p>
         </p:txBody>
       </p:sp>
@@ -1770,7 +1537,6 @@
               <a:rPr lang="en-US" dirty="0"/>
               <a:t>انتقال: "الألم وجهان لعملة واحدة — داخل الجناح وخارجه."</a:t>
             </a:r>
-            <a:endParaRPr lang="en-US" dirty="0"/>
           </a:p>
         </p:txBody>
       </p:sp>
@@ -1859,7 +1625,6 @@
               <a:t>س: ما حجم المشكلة بالأرقام؟ ج: نستهدف قياسها في التجربة الميدانية نفسها — التزامنا: أرقام مقاسة لا مزاعم. المؤشر الأدبي العالمي أن التوثيق يستهلك ما يصل لثلث وقت التمريض.
 س: لماذا التركيز على الأدوية المتشابهة؟ ج: لأنها الفشل الوحيد الذي قد يقتل مباشرة — لذلك بنينا لها طبقة اعتراض مخصصة سترونها.</a:t>
             </a:r>
-            <a:endParaRPr lang="en-US" dirty="0"/>
           </a:p>
         </p:txBody>
       </p:sp>
@@ -1947,7 +1712,6 @@
               <a:rPr lang="en-US" dirty="0"/>
               <a:t>س: كيف تسرّعون الوصول فعليًا؟ ج: المريض يصف حالته صوتيًا من بيته مرة واحدة، النظام يبنيها كملف منظم يصل للممرض قبل وصول المريض — فيبدأ العلاج من معلومات جاهزة لا من الصفر. وأسئلة الأعلام الحمراء توجه الحالة الحرجة للاتصال بالطوارئ فورًا.</a:t>
             </a:r>
-            <a:endParaRPr lang="en-US" dirty="0"/>
           </a:p>
         </p:txBody>
       </p:sp>
@@ -2035,7 +1799,6 @@
               <a:rPr lang="en-US" dirty="0"/>
               <a:t>انتقال: "بنينا المنظومة كاملة. وسأريكم ثلاث لحظات فقط منها — الثلاث التي تغيّر كل شيء."</a:t>
             </a:r>
-            <a:endParaRPr lang="en-US" dirty="0"/>
           </a:p>
         </p:txBody>
       </p:sp>
@@ -2123,7 +1886,6 @@
               <a:rPr lang="en-US" dirty="0"/>
               <a:t>س: من يكتب البيانات الطبية إذن؟ ج: البشر فقط. الذكاء الاصطناعي منظِّم وموزِّع — والممرض المرخص يراجع ويوقع. هذا قرار معماري وتنظيمي واعٍ.</a:t>
             </a:r>
-            <a:endParaRPr lang="en-US" dirty="0"/>
           </a:p>
         </p:txBody>
       </p:sp>
@@ -2212,7 +1974,6 @@
               <a:t>اليسار: قائمة الجناح (١٢ صف). اليمين: مراجعة المسودة — النص الآلي بلون البريوينكل حتى يوقّعه إنسان.
 س: ماذا لو أخطأ التفريغ؟ ج: النص غير الموثق مميز بصريًا، والصوت الأصلي محفوظ قابل للتشغيل دائمًا، والأرقام والأدوية تُعزل كرقاقات تتطلب تأكيدًا فرديًا — التالي.</a:t>
             </a:r>
-            <a:endParaRPr lang="en-US" dirty="0"/>
           </a:p>
         </p:txBody>
       </p:sp>
@@ -2302,7 +2063,6 @@
 س: لماذا لا يوجد "تأكيد الكل"؟ أليس أسرع؟ ج: لأن استبدال دواء متشابه صوتيًا هو أخطر فشل ممكن، وطبقة التأكيد الفردي هي خط الاعتراض الوحيد. حذفنا الزر من الوجود — القاعدة مفروضة في الكود وقاعدة البيانات معًا، لا في الواجهة فقط.
 س: وماذا عن النواقص؟ ج: عكسها تمامًا — لا تمنع التوقيع أبدًا (البيانات الخاطئة تقتل، الناقصة تُوثَّق وتُمرَّر) — هذه فلسفة النظام.</a:t>
             </a:r>
-            <a:endParaRPr lang="en-US" dirty="0"/>
           </a:p>
         </p:txBody>
       </p:sp>
@@ -2375,6 +2135,11 @@
 <file path=ppt/slideMasters/slideMaster1.xml><?xml version="1.0" encoding="utf-8"?>
 <p:sldMaster xmlns:a="http://schemas.openxmlformats.org/drawingml/2006/main" xmlns:r="http://schemas.openxmlformats.org/officeDocument/2006/relationships" xmlns:p="http://schemas.openxmlformats.org/presentationml/2006/main">
   <p:cSld>
+    <p:bg>
+      <p:bgRef idx="1001">
+        <a:schemeClr val="bg1"/>
+      </p:bgRef>
+    </p:bg>
     <p:spTree>
       <p:nvGrpSpPr>
         <p:cNvPr id="1" name=""/>
@@ -2657,6 +2422,7 @@
         <a:solidFill>
           <a:srgbClr val="100F0E"/>
         </a:solidFill>
+        <a:effectLst/>
       </p:bgPr>
     </p:bg>
     <p:spTree>
@@ -2675,14 +2441,14 @@
       </p:grpSpPr>
       <p:pic>
         <p:nvPicPr>
-          <p:cNvPr id="2" name="Image 0" descr="pulse-periwinkle.png">    </p:cNvPr>
+          <p:cNvPr id="2" name="Image 0" descr="pulse-periwinkle.png"/>
           <p:cNvPicPr>
             <a:picLocks noChangeAspect="1"/>
           </p:cNvPicPr>
           <p:nvPr/>
         </p:nvPicPr>
         <p:blipFill>
-          <a:blip r:embed="rId1"/>
+          <a:blip r:embed="rId3"/>
           <a:stretch>
             <a:fillRect/>
           </a:stretch>
@@ -2718,7 +2484,7 @@
           <a:bodyPr wrap="square" rtlCol="0" anchor="ctr"/>
           <a:lstStyle/>
           <a:p>
-            <a:pPr algn="ctr" indent="0" marL="0">
+            <a:pPr marL="0" indent="0" algn="ctr">
               <a:buNone/>
             </a:pPr>
             <a:r>
@@ -2757,7 +2523,7 @@
           <a:bodyPr wrap="square" rtlCol="0" anchor="ctr"/>
           <a:lstStyle/>
           <a:p>
-            <a:pPr algn="ctr" indent="0" marL="0">
+            <a:pPr marL="0" indent="0" algn="ctr">
               <a:buNone/>
             </a:pPr>
             <a:r>
@@ -2796,7 +2562,7 @@
           <a:bodyPr wrap="square" rtlCol="0" anchor="ctr"/>
           <a:lstStyle/>
           <a:p>
-            <a:pPr algn="ctr" indent="0" marL="0">
+            <a:pPr marL="0" indent="0" algn="ctr">
               <a:buNone/>
             </a:pPr>
             <a:r>
@@ -2835,7 +2601,7 @@
           <a:bodyPr wrap="square" rtlCol="0" anchor="ctr"/>
           <a:lstStyle/>
           <a:p>
-            <a:pPr algn="ctr" indent="0" marL="0">
+            <a:pPr marL="0" indent="0" algn="ctr">
               <a:buNone/>
             </a:pPr>
             <a:r>
@@ -2869,6 +2635,7 @@
         <a:solidFill>
           <a:srgbClr val="100F0E"/>
         </a:solidFill>
+        <a:effectLst/>
       </p:bgPr>
     </p:bg>
     <p:spTree>
@@ -2906,7 +2673,7 @@
           <a:bodyPr wrap="square" rtlCol="0" anchor="ctr"/>
           <a:lstStyle/>
           <a:p>
-            <a:pPr algn="r" indent="0" marL="0">
+            <a:pPr marL="0" indent="0" algn="r">
               <a:buNone/>
             </a:pPr>
             <a:r>
@@ -2926,14 +2693,14 @@
       </p:sp>
       <p:pic>
         <p:nvPicPr>
-          <p:cNvPr id="3" name="Image 0" descr="shots/c-07-ward-list-ar.png">    </p:cNvPr>
+          <p:cNvPr id="3" name="Image 0" descr="shots/c-07-ward-list-ar.png"/>
           <p:cNvPicPr>
             <a:picLocks noChangeAspect="1"/>
           </p:cNvPicPr>
           <p:nvPr/>
         </p:nvPicPr>
         <p:blipFill>
-          <a:blip r:embed="rId1"/>
+          <a:blip r:embed="rId3"/>
           <a:stretch>
             <a:fillRect/>
           </a:stretch>
@@ -2996,7 +2763,7 @@
           <a:bodyPr wrap="square" lIns="0" tIns="0" rIns="0" bIns="0" rtlCol="0" anchor="ctr"/>
           <a:lstStyle/>
           <a:p>
-            <a:pPr algn="r" indent="0" marL="0">
+            <a:pPr marL="0" indent="0" algn="r">
               <a:buNone/>
             </a:pPr>
             <a:r>
@@ -3035,7 +2802,7 @@
           <a:bodyPr wrap="square" lIns="0" tIns="0" rIns="0" bIns="0" rtlCol="0" anchor="t"/>
           <a:lstStyle/>
           <a:p>
-            <a:pPr algn="r" indent="0" marL="0">
+            <a:pPr marL="0" indent="0" algn="r">
               <a:buNone/>
             </a:pPr>
             <a:r>
@@ -3101,7 +2868,7 @@
           <a:bodyPr wrap="square" lIns="0" tIns="0" rIns="0" bIns="0" rtlCol="0" anchor="ctr"/>
           <a:lstStyle/>
           <a:p>
-            <a:pPr algn="r" indent="0" marL="0">
+            <a:pPr marL="0" indent="0" algn="r">
               <a:buNone/>
             </a:pPr>
             <a:r>
@@ -3140,7 +2907,7 @@
           <a:bodyPr wrap="square" lIns="0" tIns="0" rIns="0" bIns="0" rtlCol="0" anchor="t"/>
           <a:lstStyle/>
           <a:p>
-            <a:pPr algn="r" indent="0" marL="0">
+            <a:pPr marL="0" indent="0" algn="r">
               <a:buNone/>
             </a:pPr>
             <a:r>
@@ -3206,7 +2973,7 @@
           <a:bodyPr wrap="square" lIns="0" tIns="0" rIns="0" bIns="0" rtlCol="0" anchor="ctr"/>
           <a:lstStyle/>
           <a:p>
-            <a:pPr algn="r" indent="0" marL="0">
+            <a:pPr marL="0" indent="0" algn="r">
               <a:buNone/>
             </a:pPr>
             <a:r>
@@ -3245,7 +3012,7 @@
           <a:bodyPr wrap="square" lIns="0" tIns="0" rIns="0" bIns="0" rtlCol="0" anchor="t"/>
           <a:lstStyle/>
           <a:p>
-            <a:pPr algn="r" indent="0" marL="0">
+            <a:pPr marL="0" indent="0" algn="r">
               <a:buNone/>
             </a:pPr>
             <a:r>
@@ -3284,7 +3051,7 @@
           <a:bodyPr wrap="square" rtlCol="0" anchor="ctr"/>
           <a:lstStyle/>
           <a:p>
-            <a:pPr algn="r" indent="0" marL="0">
+            <a:pPr marL="0" indent="0" algn="r">
               <a:buNone/>
             </a:pPr>
             <a:r>
@@ -3318,6 +3085,7 @@
         <a:solidFill>
           <a:srgbClr val="FAF9F7"/>
         </a:solidFill>
+        <a:effectLst/>
       </p:bgPr>
     </p:bg>
     <p:spTree>
@@ -3355,7 +3123,7 @@
           <a:bodyPr wrap="square" rtlCol="0" anchor="ctr"/>
           <a:lstStyle/>
           <a:p>
-            <a:pPr algn="r" indent="0" marL="0">
+            <a:pPr marL="0" indent="0" algn="r">
               <a:buNone/>
             </a:pPr>
             <a:r>
@@ -3427,14 +3195,14 @@
       </p:sp>
       <p:pic>
         <p:nvPicPr>
-          <p:cNvPr id="5" name="Image 0" descr="ic-users.png">    </p:cNvPr>
+          <p:cNvPr id="5" name="Image 0" descr="ic-users.png"/>
           <p:cNvPicPr>
             <a:picLocks noChangeAspect="1"/>
           </p:cNvPicPr>
           <p:nvPr/>
         </p:nvPicPr>
         <p:blipFill>
-          <a:blip r:embed="rId1"/>
+          <a:blip r:embed="rId3"/>
           <a:stretch>
             <a:fillRect/>
           </a:stretch>
@@ -3470,7 +3238,7 @@
           <a:bodyPr wrap="square" rtlCol="0" anchor="ctr"/>
           <a:lstStyle/>
           <a:p>
-            <a:pPr algn="ctr" indent="0" marL="0">
+            <a:pPr marL="0" indent="0" algn="ctr">
               <a:buNone/>
             </a:pPr>
             <a:r>
@@ -3509,7 +3277,7 @@
           <a:bodyPr wrap="square" rtlCol="0" anchor="t"/>
           <a:lstStyle/>
           <a:p>
-            <a:pPr algn="ctr" indent="0" marL="0">
+            <a:pPr marL="0" indent="0" algn="ctr">
               <a:buNone/>
             </a:pPr>
             <a:r>
@@ -3581,14 +3349,14 @@
       </p:sp>
       <p:pic>
         <p:nvPicPr>
-          <p:cNvPr id="10" name="Image 1" descr="ic-zap.png">    </p:cNvPr>
+          <p:cNvPr id="10" name="Image 1" descr="ic-zap.png"/>
           <p:cNvPicPr>
             <a:picLocks noChangeAspect="1"/>
           </p:cNvPicPr>
           <p:nvPr/>
         </p:nvPicPr>
         <p:blipFill>
-          <a:blip r:embed="rId2"/>
+          <a:blip r:embed="rId4"/>
           <a:stretch>
             <a:fillRect/>
           </a:stretch>
@@ -3624,7 +3392,7 @@
           <a:bodyPr wrap="square" rtlCol="0" anchor="ctr"/>
           <a:lstStyle/>
           <a:p>
-            <a:pPr algn="ctr" indent="0" marL="0">
+            <a:pPr marL="0" indent="0" algn="ctr">
               <a:buNone/>
             </a:pPr>
             <a:r>
@@ -3663,7 +3431,7 @@
           <a:bodyPr wrap="square" rtlCol="0" anchor="t"/>
           <a:lstStyle/>
           <a:p>
-            <a:pPr algn="ctr" indent="0" marL="0">
+            <a:pPr marL="0" indent="0" algn="ctr">
               <a:buNone/>
             </a:pPr>
             <a:r>
@@ -3735,14 +3503,14 @@
       </p:sp>
       <p:pic>
         <p:nvPicPr>
-          <p:cNvPr id="15" name="Image 2" descr="ic-check.png">    </p:cNvPr>
+          <p:cNvPr id="15" name="Image 2" descr="ic-check.png"/>
           <p:cNvPicPr>
             <a:picLocks noChangeAspect="1"/>
           </p:cNvPicPr>
           <p:nvPr/>
         </p:nvPicPr>
         <p:blipFill>
-          <a:blip r:embed="rId3"/>
+          <a:blip r:embed="rId5"/>
           <a:stretch>
             <a:fillRect/>
           </a:stretch>
@@ -3778,7 +3546,7 @@
           <a:bodyPr wrap="square" rtlCol="0" anchor="ctr"/>
           <a:lstStyle/>
           <a:p>
-            <a:pPr algn="ctr" indent="0" marL="0">
+            <a:pPr marL="0" indent="0" algn="ctr">
               <a:buNone/>
             </a:pPr>
             <a:r>
@@ -3817,7 +3585,7 @@
           <a:bodyPr wrap="square" rtlCol="0" anchor="t"/>
           <a:lstStyle/>
           <a:p>
-            <a:pPr algn="ctr" indent="0" marL="0">
+            <a:pPr marL="0" indent="0" algn="ctr">
               <a:buNone/>
             </a:pPr>
             <a:r>
@@ -3856,7 +3624,7 @@
           <a:bodyPr wrap="square" rtlCol="0" anchor="ctr"/>
           <a:lstStyle/>
           <a:p>
-            <a:pPr algn="ctr" indent="0" marL="0">
+            <a:pPr marL="0" indent="0" algn="ctr" rtl="1">
               <a:buNone/>
             </a:pPr>
             <a:r>
@@ -3890,6 +3658,7 @@
         <a:solidFill>
           <a:srgbClr val="100F0E"/>
         </a:solidFill>
+        <a:effectLst/>
       </p:bgPr>
     </p:bg>
     <p:spTree>
@@ -3927,7 +3696,7 @@
           <a:bodyPr wrap="square" rtlCol="0" anchor="ctr"/>
           <a:lstStyle/>
           <a:p>
-            <a:pPr algn="r" indent="0" marL="0">
+            <a:pPr marL="0" indent="0" algn="r">
               <a:buNone/>
             </a:pPr>
             <a:r>
@@ -3947,55 +3716,7 @@
       </p:sp>
       <p:pic>
         <p:nvPicPr>
-          <p:cNvPr id="3" name="Image 0" descr="shots/p-02-home.png">    </p:cNvPr>
-          <p:cNvPicPr>
-            <a:picLocks noChangeAspect="1"/>
-          </p:cNvPicPr>
-          <p:nvPr/>
-        </p:nvPicPr>
-        <p:blipFill>
-          <a:blip r:embed="rId1"/>
-          <a:stretch>
-            <a:fillRect/>
-          </a:stretch>
-        </p:blipFill>
-        <p:spPr>
-          <a:xfrm>
-            <a:off x="9418320" y="1325880"/>
-            <a:ext cx="2250248" cy="4892040"/>
-          </a:xfrm>
-          <a:prstGeom prst="rect">
-            <a:avLst/>
-          </a:prstGeom>
-        </p:spPr>
-      </p:pic>
-      <p:pic>
-        <p:nvPicPr>
-          <p:cNvPr id="4" name="Image 1" descr="shots/p-03-red-flag.png">    </p:cNvPr>
-          <p:cNvPicPr>
-            <a:picLocks noChangeAspect="1"/>
-          </p:cNvPicPr>
-          <p:nvPr/>
-        </p:nvPicPr>
-        <p:blipFill>
-          <a:blip r:embed="rId2"/>
-          <a:stretch>
-            <a:fillRect/>
-          </a:stretch>
-        </p:blipFill>
-        <p:spPr>
-          <a:xfrm>
-            <a:off x="6858000" y="1325880"/>
-            <a:ext cx="2250248" cy="4892040"/>
-          </a:xfrm>
-          <a:prstGeom prst="rect">
-            <a:avLst/>
-          </a:prstGeom>
-        </p:spPr>
-      </p:pic>
-      <p:pic>
-        <p:nvPicPr>
-          <p:cNvPr id="5" name="Image 2" descr="shots/p-04-emergency-interrupt.png">    </p:cNvPr>
+          <p:cNvPr id="3" name="Image 0" descr="shots/p-02-home.png"/>
           <p:cNvPicPr>
             <a:picLocks noChangeAspect="1"/>
           </p:cNvPicPr>
@@ -4009,6 +3730,54 @@
         </p:blipFill>
         <p:spPr>
           <a:xfrm>
+            <a:off x="9418320" y="1325880"/>
+            <a:ext cx="2250248" cy="4892040"/>
+          </a:xfrm>
+          <a:prstGeom prst="rect">
+            <a:avLst/>
+          </a:prstGeom>
+        </p:spPr>
+      </p:pic>
+      <p:pic>
+        <p:nvPicPr>
+          <p:cNvPr id="4" name="Image 1" descr="shots/p-03-red-flag.png"/>
+          <p:cNvPicPr>
+            <a:picLocks noChangeAspect="1"/>
+          </p:cNvPicPr>
+          <p:nvPr/>
+        </p:nvPicPr>
+        <p:blipFill>
+          <a:blip r:embed="rId4"/>
+          <a:stretch>
+            <a:fillRect/>
+          </a:stretch>
+        </p:blipFill>
+        <p:spPr>
+          <a:xfrm>
+            <a:off x="6858000" y="1325880"/>
+            <a:ext cx="2250248" cy="4892040"/>
+          </a:xfrm>
+          <a:prstGeom prst="rect">
+            <a:avLst/>
+          </a:prstGeom>
+        </p:spPr>
+      </p:pic>
+      <p:pic>
+        <p:nvPicPr>
+          <p:cNvPr id="5" name="Image 2" descr="shots/p-04-emergency-interrupt.png"/>
+          <p:cNvPicPr>
+            <a:picLocks noChangeAspect="1"/>
+          </p:cNvPicPr>
+          <p:nvPr/>
+        </p:nvPicPr>
+        <p:blipFill>
+          <a:blip r:embed="rId5"/>
+          <a:stretch>
+            <a:fillRect/>
+          </a:stretch>
+        </p:blipFill>
+        <p:spPr>
+          <a:xfrm>
             <a:off x="4297680" y="1325880"/>
             <a:ext cx="2250248" cy="4892040"/>
           </a:xfrm>
@@ -4038,7 +3807,7 @@
           <a:bodyPr wrap="square" rtlCol="0" anchor="t"/>
           <a:lstStyle/>
           <a:p>
-            <a:pPr algn="r" marL="342900" indent="-342900">
+            <a:pPr marL="342900" indent="-342900" algn="r" rtl="1">
               <a:buSzPct val="100000"/>
               <a:buChar char="•"/>
             </a:pPr>
@@ -4078,7 +3847,7 @@
           <a:bodyPr wrap="square" rtlCol="0" anchor="t"/>
           <a:lstStyle/>
           <a:p>
-            <a:pPr algn="r" marL="342900" indent="-342900">
+            <a:pPr marL="342900" indent="-342900" algn="r" rtl="1">
               <a:buSzPct val="100000"/>
               <a:buChar char="•"/>
             </a:pPr>
@@ -4118,7 +3887,7 @@
           <a:bodyPr wrap="square" rtlCol="0" anchor="t"/>
           <a:lstStyle/>
           <a:p>
-            <a:pPr algn="r" marL="342900" indent="-342900">
+            <a:pPr marL="342900" indent="-342900" algn="r" rtl="1">
               <a:buSzPct val="100000"/>
               <a:buChar char="•"/>
             </a:pPr>
@@ -4153,6 +3922,7 @@
         <a:solidFill>
           <a:srgbClr val="FAF9F7"/>
         </a:solidFill>
+        <a:effectLst/>
       </p:bgPr>
     </p:bg>
     <p:spTree>
@@ -4190,7 +3960,7 @@
           <a:bodyPr wrap="square" rtlCol="0" anchor="ctr"/>
           <a:lstStyle/>
           <a:p>
-            <a:pPr algn="r" indent="0" marL="0">
+            <a:pPr marL="0" indent="0" algn="r">
               <a:buNone/>
             </a:pPr>
             <a:r>
@@ -4262,14 +4032,14 @@
       </p:sp>
       <p:pic>
         <p:nvPicPr>
-          <p:cNvPr id="5" name="Image 0" descr="ic-clock.png">    </p:cNvPr>
+          <p:cNvPr id="5" name="Image 0" descr="ic-clock.png"/>
           <p:cNvPicPr>
             <a:picLocks noChangeAspect="1"/>
           </p:cNvPicPr>
           <p:nvPr/>
         </p:nvPicPr>
         <p:blipFill>
-          <a:blip r:embed="rId1"/>
+          <a:blip r:embed="rId3"/>
           <a:stretch>
             <a:fillRect/>
           </a:stretch>
@@ -4305,7 +4075,7 @@
           <a:bodyPr wrap="square" lIns="0" tIns="0" rIns="0" bIns="0" rtlCol="0" anchor="ctr"/>
           <a:lstStyle/>
           <a:p>
-            <a:pPr algn="r" indent="0" marL="0">
+            <a:pPr marL="0" indent="0" algn="r">
               <a:buNone/>
             </a:pPr>
             <a:r>
@@ -4344,7 +4114,7 @@
           <a:bodyPr wrap="square" lIns="0" tIns="0" rIns="0" bIns="0" rtlCol="0" anchor="t"/>
           <a:lstStyle/>
           <a:p>
-            <a:pPr algn="r" indent="0" marL="0">
+            <a:pPr marL="0" indent="0" algn="r">
               <a:buNone/>
             </a:pPr>
             <a:r>
@@ -4416,14 +4186,14 @@
       </p:sp>
       <p:pic>
         <p:nvPicPr>
-          <p:cNvPr id="10" name="Image 1" descr="ic-users.png">    </p:cNvPr>
+          <p:cNvPr id="10" name="Image 1" descr="ic-users.png"/>
           <p:cNvPicPr>
             <a:picLocks noChangeAspect="1"/>
           </p:cNvPicPr>
           <p:nvPr/>
         </p:nvPicPr>
         <p:blipFill>
-          <a:blip r:embed="rId2"/>
+          <a:blip r:embed="rId4"/>
           <a:stretch>
             <a:fillRect/>
           </a:stretch>
@@ -4459,7 +4229,7 @@
           <a:bodyPr wrap="square" lIns="0" tIns="0" rIns="0" bIns="0" rtlCol="0" anchor="ctr"/>
           <a:lstStyle/>
           <a:p>
-            <a:pPr algn="r" indent="0" marL="0">
+            <a:pPr marL="0" indent="0" algn="r">
               <a:buNone/>
             </a:pPr>
             <a:r>
@@ -4498,7 +4268,7 @@
           <a:bodyPr wrap="square" lIns="0" tIns="0" rIns="0" bIns="0" rtlCol="0" anchor="t"/>
           <a:lstStyle/>
           <a:p>
-            <a:pPr algn="r" indent="0" marL="0">
+            <a:pPr marL="0" indent="0" algn="r">
               <a:buNone/>
             </a:pPr>
             <a:r>
@@ -4570,14 +4340,14 @@
       </p:sp>
       <p:pic>
         <p:nvPicPr>
-          <p:cNvPr id="15" name="Image 2" descr="ic-shield.png">    </p:cNvPr>
+          <p:cNvPr id="15" name="Image 2" descr="ic-shield.png"/>
           <p:cNvPicPr>
             <a:picLocks noChangeAspect="1"/>
           </p:cNvPicPr>
           <p:nvPr/>
         </p:nvPicPr>
         <p:blipFill>
-          <a:blip r:embed="rId3"/>
+          <a:blip r:embed="rId5"/>
           <a:stretch>
             <a:fillRect/>
           </a:stretch>
@@ -4613,7 +4383,7 @@
           <a:bodyPr wrap="square" lIns="0" tIns="0" rIns="0" bIns="0" rtlCol="0" anchor="ctr"/>
           <a:lstStyle/>
           <a:p>
-            <a:pPr algn="r" indent="0" marL="0">
+            <a:pPr marL="0" indent="0" algn="r">
               <a:buNone/>
             </a:pPr>
             <a:r>
@@ -4652,7 +4422,7 @@
           <a:bodyPr wrap="square" lIns="0" tIns="0" rIns="0" bIns="0" rtlCol="0" anchor="t"/>
           <a:lstStyle/>
           <a:p>
-            <a:pPr algn="r" indent="0" marL="0">
+            <a:pPr marL="0" indent="0" algn="r">
               <a:buNone/>
             </a:pPr>
             <a:r>
@@ -4691,11 +4461,9 @@
           <a:bodyPr wrap="square" rtlCol="0" anchor="ctr"/>
           <a:lstStyle/>
           <a:p>
-            <a:pPr algn="ctr" indent="0" marL="0">
-              <a:buNone/>
-            </a:pPr>
-            <a:r>
-              <a:rPr lang="en-US" sz="1300" dirty="0">
+            <a:pPr algn="ctr" rtl="1"/>
+            <a:r>
+              <a:rPr lang="en-US" sz="1300" dirty="0" err="1">
                 <a:solidFill>
                   <a:srgbClr val="2D4A8A"/>
                 </a:solidFill>
@@ -4703,7 +4471,62 @@
                 <a:ea typeface="Courier New" pitchFamily="34" charset="-122"/>
                 <a:cs typeface="Courier New" pitchFamily="34" charset="-120"/>
               </a:rPr>
-              <a:t>منشورة الآن: afia-dashboard.vercel.app</a:t>
+              <a:t>منشورة</a:t>
+            </a:r>
+            <a:r>
+              <a:rPr lang="en-US" sz="1300" dirty="0">
+                <a:solidFill>
+                  <a:srgbClr val="2D4A8A"/>
+                </a:solidFill>
+                <a:latin typeface="Courier New" pitchFamily="34" charset="0"/>
+                <a:ea typeface="Courier New" pitchFamily="34" charset="-122"/>
+                <a:cs typeface="Courier New" pitchFamily="34" charset="-120"/>
+              </a:rPr>
+              <a:t> </a:t>
+            </a:r>
+            <a:r>
+              <a:rPr lang="en-US" sz="1300" dirty="0" err="1">
+                <a:solidFill>
+                  <a:srgbClr val="2D4A8A"/>
+                </a:solidFill>
+                <a:latin typeface="Courier New" pitchFamily="34" charset="0"/>
+                <a:ea typeface="Courier New" pitchFamily="34" charset="-122"/>
+                <a:cs typeface="Courier New" pitchFamily="34" charset="-120"/>
+              </a:rPr>
+              <a:t>الآن</a:t>
+            </a:r>
+            <a:r>
+              <a:rPr lang="en-US" sz="1300" dirty="0">
+                <a:solidFill>
+                  <a:srgbClr val="2D4A8A"/>
+                </a:solidFill>
+                <a:latin typeface="Courier New" pitchFamily="34" charset="0"/>
+                <a:ea typeface="Courier New" pitchFamily="34" charset="-122"/>
+                <a:cs typeface="Courier New" pitchFamily="34" charset="-120"/>
+              </a:rPr>
+              <a:t> :</a:t>
+            </a:r>
+            <a:r>
+              <a:rPr lang="ar-SA" sz="1300" dirty="0">
+                <a:solidFill>
+                  <a:srgbClr val="2D4A8A"/>
+                </a:solidFill>
+                <a:latin typeface="Courier New" pitchFamily="34" charset="0"/>
+                <a:ea typeface="Courier New" pitchFamily="34" charset="-122"/>
+                <a:cs typeface="Courier New" pitchFamily="34" charset="-120"/>
+              </a:rPr>
+              <a:t> </a:t>
+            </a:r>
+            <a:r>
+              <a:rPr lang="en-US" sz="1300" dirty="0">
+                <a:solidFill>
+                  <a:srgbClr val="2D4A8A"/>
+                </a:solidFill>
+                <a:latin typeface="Courier New" pitchFamily="34" charset="0"/>
+                <a:ea typeface="Courier New" pitchFamily="34" charset="-122"/>
+                <a:cs typeface="Courier New" pitchFamily="34" charset="-120"/>
+              </a:rPr>
+              <a:t> afia-dashboard.vercel.app</a:t>
             </a:r>
             <a:endParaRPr lang="en-US" sz="1300" dirty="0"/>
           </a:p>
@@ -4725,6 +4548,7 @@
         <a:solidFill>
           <a:srgbClr val="100F0E"/>
         </a:solidFill>
+        <a:effectLst/>
       </p:bgPr>
     </p:bg>
     <p:spTree>
@@ -4762,7 +4586,7 @@
           <a:bodyPr wrap="square" rtlCol="0" anchor="ctr"/>
           <a:lstStyle/>
           <a:p>
-            <a:pPr algn="l" indent="0" marL="0">
+            <a:pPr marL="0" indent="0" algn="l">
               <a:buNone/>
             </a:pPr>
             <a:r>
@@ -4801,7 +4625,7 @@
           <a:bodyPr wrap="square" rtlCol="0" anchor="ctr"/>
           <a:lstStyle/>
           <a:p>
-            <a:pPr algn="r" indent="0" marL="0">
+            <a:pPr marL="0" indent="0" algn="r">
               <a:buNone/>
             </a:pPr>
             <a:r>
@@ -4840,7 +4664,7 @@
           <a:bodyPr wrap="square" rtlCol="0" anchor="ctr"/>
           <a:lstStyle/>
           <a:p>
-            <a:pPr algn="r" indent="0" marL="0">
+            <a:pPr marL="0" indent="0" algn="r">
               <a:buNone/>
             </a:pPr>
             <a:r>
@@ -4860,14 +4684,14 @@
       </p:sp>
       <p:pic>
         <p:nvPicPr>
-          <p:cNvPr id="5" name="Image 0" descr="pulse-faint.png">    </p:cNvPr>
+          <p:cNvPr id="5" name="Image 0" descr="pulse-faint.png"/>
           <p:cNvPicPr>
             <a:picLocks noChangeAspect="1"/>
           </p:cNvPicPr>
           <p:nvPr/>
         </p:nvPicPr>
         <p:blipFill>
-          <a:blip r:embed="rId1"/>
+          <a:blip r:embed="rId3"/>
           <a:stretch>
             <a:fillRect/>
           </a:stretch>
@@ -4898,6 +4722,7 @@
         <a:solidFill>
           <a:srgbClr val="FAF9F7"/>
         </a:solidFill>
+        <a:effectLst/>
       </p:bgPr>
     </p:bg>
     <p:spTree>
@@ -4935,7 +4760,7 @@
           <a:bodyPr wrap="square" rtlCol="0" anchor="ctr"/>
           <a:lstStyle/>
           <a:p>
-            <a:pPr algn="r" indent="0" marL="0">
+            <a:pPr marL="0" indent="0" algn="r">
               <a:buNone/>
             </a:pPr>
             <a:r>
@@ -5001,7 +4826,7 @@
           <a:bodyPr wrap="square" lIns="0" tIns="0" rIns="0" bIns="0" rtlCol="0" anchor="ctr"/>
           <a:lstStyle/>
           <a:p>
-            <a:pPr algn="ctr" indent="0" marL="0">
+            <a:pPr marL="0" indent="0" algn="ctr">
               <a:buNone/>
             </a:pPr>
             <a:r>
@@ -5090,7 +4915,7 @@
           <a:bodyPr wrap="square" lIns="0" tIns="0" rIns="0" bIns="0" rtlCol="0" anchor="ctr"/>
           <a:lstStyle/>
           <a:p>
-            <a:pPr algn="ctr" indent="0" marL="0">
+            <a:pPr marL="0" indent="0" algn="ctr">
               <a:buNone/>
             </a:pPr>
             <a:r>
@@ -5179,7 +5004,7 @@
           <a:bodyPr wrap="square" lIns="0" tIns="0" rIns="0" bIns="0" rtlCol="0" anchor="ctr"/>
           <a:lstStyle/>
           <a:p>
-            <a:pPr algn="ctr" indent="0" marL="0">
+            <a:pPr marL="0" indent="0" algn="ctr">
               <a:buNone/>
             </a:pPr>
             <a:r>
@@ -5263,7 +5088,7 @@
           <a:bodyPr wrap="square" rtlCol="0" anchor="ctr"/>
           <a:lstStyle/>
           <a:p>
-            <a:pPr algn="ctr" indent="0" marL="0">
+            <a:pPr marL="0" indent="0" algn="r" rtl="1">
               <a:buNone/>
             </a:pPr>
             <a:r>
@@ -5277,9 +5102,6 @@
               </a:rPr>
               <a:t>Firebase — قاعدة حية واحدة    </a:t>
             </a:r>
-            <a:pPr algn="ctr" indent="0" marL="0">
-              <a:buNone/>
-            </a:pPr>
             <a:r>
               <a:rPr lang="ar-SA" altLang="en-US" sz="1400" dirty="0">
                 <a:solidFill>
@@ -5316,7 +5138,7 @@
           <a:bodyPr wrap="square" rtlCol="0" anchor="t"/>
           <a:lstStyle/>
           <a:p>
-            <a:pPr algn="r" marL="342900" indent="-342900">
+            <a:pPr marL="342900" indent="-342900" algn="r" rtl="1">
               <a:buSzPct val="100000"/>
               <a:buChar char="•"/>
             </a:pPr>
@@ -5356,7 +5178,7 @@
           <a:bodyPr wrap="square" rtlCol="0" anchor="t"/>
           <a:lstStyle/>
           <a:p>
-            <a:pPr algn="r" marL="342900" indent="-342900">
+            <a:pPr marL="342900" indent="-342900" algn="r" rtl="1">
               <a:buSzPct val="100000"/>
               <a:buChar char="•"/>
             </a:pPr>
@@ -5396,7 +5218,7 @@
           <a:bodyPr wrap="square" rtlCol="0" anchor="t"/>
           <a:lstStyle/>
           <a:p>
-            <a:pPr algn="r" marL="342900" indent="-342900">
+            <a:pPr marL="342900" indent="-342900" algn="r" rtl="1">
               <a:buSzPct val="100000"/>
               <a:buChar char="•"/>
             </a:pPr>
@@ -5431,6 +5253,7 @@
         <a:solidFill>
           <a:srgbClr val="100F0E"/>
         </a:solidFill>
+        <a:effectLst/>
       </p:bgPr>
     </p:bg>
     <p:spTree>
@@ -5455,7 +5278,7 @@
         </p:nvSpPr>
         <p:spPr>
           <a:xfrm>
-            <a:off x="640080" y="548640"/>
+            <a:off x="-274321" y="563477"/>
             <a:ext cx="10972800" cy="731520"/>
           </a:xfrm>
           <a:prstGeom prst="rect">
@@ -5468,7 +5291,7 @@
           <a:bodyPr wrap="square" rtlCol="0" anchor="ctr"/>
           <a:lstStyle/>
           <a:p>
-            <a:pPr algn="r" indent="0" marL="0">
+            <a:pPr marL="0" indent="0" algn="r">
               <a:buNone/>
             </a:pPr>
             <a:r>
@@ -5513,14 +5336,14 @@
       </p:sp>
       <p:pic>
         <p:nvPicPr>
-          <p:cNvPr id="4" name="Image 0" descr="ic-sparkle.png">    </p:cNvPr>
+          <p:cNvPr id="4" name="Image 0" descr="ic-sparkle.png"/>
           <p:cNvPicPr>
             <a:picLocks noChangeAspect="1"/>
           </p:cNvPicPr>
           <p:nvPr/>
         </p:nvPicPr>
         <p:blipFill>
-          <a:blip r:embed="rId1"/>
+          <a:blip r:embed="rId3"/>
           <a:stretch>
             <a:fillRect/>
           </a:stretch>
@@ -5556,7 +5379,7 @@
           <a:bodyPr wrap="square" rtlCol="0" anchor="ctr"/>
           <a:lstStyle/>
           <a:p>
-            <a:pPr algn="r" indent="0" marL="0">
+            <a:pPr marL="0" indent="0" algn="r">
               <a:lnSpc>
                 <a:spcPct val="130000"/>
               </a:lnSpc>
@@ -5576,7 +5399,7 @@
             <a:endParaRPr lang="ar-SA" sz="2000" dirty="0"/>
           </a:p>
           <a:p>
-            <a:pPr algn="r" indent="0" marL="0">
+            <a:pPr marL="0" indent="0" algn="r">
               <a:lnSpc>
                 <a:spcPct val="130000"/>
               </a:lnSpc>
@@ -5624,14 +5447,14 @@
       </p:sp>
       <p:pic>
         <p:nvPicPr>
-          <p:cNvPr id="7" name="Image 1" descr="ic-shield.png">    </p:cNvPr>
+          <p:cNvPr id="7" name="Image 1" descr="ic-shield.png"/>
           <p:cNvPicPr>
             <a:picLocks noChangeAspect="1"/>
           </p:cNvPicPr>
           <p:nvPr/>
         </p:nvPicPr>
         <p:blipFill>
-          <a:blip r:embed="rId2"/>
+          <a:blip r:embed="rId4"/>
           <a:stretch>
             <a:fillRect/>
           </a:stretch>
@@ -5667,7 +5490,7 @@
           <a:bodyPr wrap="square" rtlCol="0" anchor="ctr"/>
           <a:lstStyle/>
           <a:p>
-            <a:pPr algn="r" indent="0" marL="0">
+            <a:pPr marL="0" indent="0" algn="r">
               <a:buNone/>
             </a:pPr>
             <a:r>
@@ -5712,14 +5535,14 @@
       </p:sp>
       <p:pic>
         <p:nvPicPr>
-          <p:cNvPr id="10" name="Image 2" descr="ic-zap.png">    </p:cNvPr>
+          <p:cNvPr id="10" name="Image 2" descr="ic-zap.png"/>
           <p:cNvPicPr>
             <a:picLocks noChangeAspect="1"/>
           </p:cNvPicPr>
           <p:nvPr/>
         </p:nvPicPr>
         <p:blipFill>
-          <a:blip r:embed="rId3"/>
+          <a:blip r:embed="rId5"/>
           <a:stretch>
             <a:fillRect/>
           </a:stretch>
@@ -5755,7 +5578,7 @@
           <a:bodyPr wrap="square" rtlCol="0" anchor="ctr"/>
           <a:lstStyle/>
           <a:p>
-            <a:pPr algn="r" indent="0" marL="0">
+            <a:pPr marL="0" indent="0" algn="r">
               <a:buNone/>
             </a:pPr>
             <a:r>
@@ -5800,14 +5623,14 @@
       </p:sp>
       <p:pic>
         <p:nvPicPr>
-          <p:cNvPr id="13" name="Image 3" descr="ic-check.png">    </p:cNvPr>
+          <p:cNvPr id="13" name="Image 3" descr="ic-check.png"/>
           <p:cNvPicPr>
             <a:picLocks noChangeAspect="1"/>
           </p:cNvPicPr>
           <p:nvPr/>
         </p:nvPicPr>
         <p:blipFill>
-          <a:blip r:embed="rId4"/>
+          <a:blip r:embed="rId6"/>
           <a:stretch>
             <a:fillRect/>
           </a:stretch>
@@ -5843,7 +5666,7 @@
           <a:bodyPr wrap="square" rtlCol="0" anchor="ctr"/>
           <a:lstStyle/>
           <a:p>
-            <a:pPr algn="r" indent="0" marL="0">
+            <a:pPr marL="0" indent="0" algn="r">
               <a:buNone/>
             </a:pPr>
             <a:r>
@@ -5888,14 +5711,14 @@
       </p:sp>
       <p:pic>
         <p:nvPicPr>
-          <p:cNvPr id="16" name="Image 4" descr="ic-heart.png">    </p:cNvPr>
+          <p:cNvPr id="16" name="Image 4" descr="ic-heart.png"/>
           <p:cNvPicPr>
             <a:picLocks noChangeAspect="1"/>
           </p:cNvPicPr>
           <p:nvPr/>
         </p:nvPicPr>
         <p:blipFill>
-          <a:blip r:embed="rId5"/>
+          <a:blip r:embed="rId7"/>
           <a:stretch>
             <a:fillRect/>
           </a:stretch>
@@ -5931,7 +5754,7 @@
           <a:bodyPr wrap="square" rtlCol="0" anchor="ctr"/>
           <a:lstStyle/>
           <a:p>
-            <a:pPr algn="r" indent="0" marL="0">
+            <a:pPr marL="0" indent="0" algn="r">
               <a:buNone/>
             </a:pPr>
             <a:r>
@@ -5965,6 +5788,7 @@
         <a:solidFill>
           <a:srgbClr val="FAF9F7"/>
         </a:solidFill>
+        <a:effectLst/>
       </p:bgPr>
     </p:bg>
     <p:spTree>
@@ -6002,7 +5826,7 @@
           <a:bodyPr wrap="square" rtlCol="0" anchor="ctr"/>
           <a:lstStyle/>
           <a:p>
-            <a:pPr algn="r" indent="0" marL="0">
+            <a:pPr marL="0" indent="0" algn="r">
               <a:buNone/>
             </a:pPr>
             <a:r>
@@ -6068,7 +5892,7 @@
           <a:bodyPr wrap="square" lIns="0" tIns="0" rIns="0" bIns="0" rtlCol="0" anchor="ctr"/>
           <a:lstStyle/>
           <a:p>
-            <a:pPr algn="ctr" indent="0" marL="0">
+            <a:pPr marL="0" indent="0" algn="ctr">
               <a:buNone/>
             </a:pPr>
             <a:r>
@@ -6107,7 +5931,7 @@
           <a:bodyPr wrap="square" rtlCol="0" anchor="t"/>
           <a:lstStyle/>
           <a:p>
-            <a:pPr algn="ctr" indent="0" marL="0">
+            <a:pPr marL="0" indent="0" algn="ctr">
               <a:buNone/>
             </a:pPr>
             <a:r>
@@ -6173,7 +5997,7 @@
           <a:bodyPr wrap="square" lIns="0" tIns="0" rIns="0" bIns="0" rtlCol="0" anchor="ctr"/>
           <a:lstStyle/>
           <a:p>
-            <a:pPr algn="ctr" indent="0" marL="0">
+            <a:pPr marL="0" indent="0" algn="ctr">
               <a:buNone/>
             </a:pPr>
             <a:r>
@@ -6212,7 +6036,7 @@
           <a:bodyPr wrap="square" rtlCol="0" anchor="t"/>
           <a:lstStyle/>
           <a:p>
-            <a:pPr algn="ctr" indent="0" marL="0">
+            <a:pPr marL="0" indent="0" algn="ctr">
               <a:buNone/>
             </a:pPr>
             <a:r>
@@ -6278,7 +6102,7 @@
           <a:bodyPr wrap="square" lIns="0" tIns="0" rIns="0" bIns="0" rtlCol="0" anchor="ctr"/>
           <a:lstStyle/>
           <a:p>
-            <a:pPr algn="ctr" indent="0" marL="0">
+            <a:pPr marL="0" indent="0" algn="ctr">
               <a:buNone/>
             </a:pPr>
             <a:r>
@@ -6317,7 +6141,7 @@
           <a:bodyPr wrap="square" rtlCol="0" anchor="t"/>
           <a:lstStyle/>
           <a:p>
-            <a:pPr algn="ctr" indent="0" marL="0">
+            <a:pPr marL="0" indent="0" algn="ctr">
               <a:buNone/>
             </a:pPr>
             <a:r>
@@ -6383,7 +6207,7 @@
           <a:bodyPr wrap="square" lIns="0" tIns="0" rIns="0" bIns="0" rtlCol="0" anchor="ctr"/>
           <a:lstStyle/>
           <a:p>
-            <a:pPr algn="ctr" indent="0" marL="0">
+            <a:pPr marL="0" indent="0" algn="ctr">
               <a:buNone/>
             </a:pPr>
             <a:r>
@@ -6422,7 +6246,7 @@
           <a:bodyPr wrap="square" rtlCol="0" anchor="t"/>
           <a:lstStyle/>
           <a:p>
-            <a:pPr algn="ctr" indent="0" marL="0">
+            <a:pPr marL="0" indent="0" algn="ctr">
               <a:buNone/>
             </a:pPr>
             <a:r>
@@ -6461,7 +6285,7 @@
           <a:bodyPr wrap="square" rtlCol="0" anchor="ctr"/>
           <a:lstStyle/>
           <a:p>
-            <a:pPr algn="r" indent="0" marL="0">
+            <a:pPr marL="0" indent="0" algn="r">
               <a:lnSpc>
                 <a:spcPct val="130000"/>
               </a:lnSpc>
@@ -6498,6 +6322,7 @@
         <a:solidFill>
           <a:srgbClr val="100F0E"/>
         </a:solidFill>
+        <a:effectLst/>
       </p:bgPr>
     </p:bg>
     <p:spTree>
@@ -6535,7 +6360,7 @@
           <a:bodyPr wrap="square" rtlCol="0" anchor="ctr"/>
           <a:lstStyle/>
           <a:p>
-            <a:pPr algn="l" indent="0" marL="0">
+            <a:pPr marL="0" indent="0" algn="l">
               <a:buNone/>
             </a:pPr>
             <a:r>
@@ -6574,7 +6399,7 @@
           <a:bodyPr wrap="square" rtlCol="0" anchor="ctr"/>
           <a:lstStyle/>
           <a:p>
-            <a:pPr algn="r" indent="0" marL="0">
+            <a:pPr marL="0" indent="0" algn="r">
               <a:buNone/>
             </a:pPr>
             <a:r>
@@ -6613,7 +6438,7 @@
           <a:bodyPr wrap="square" rtlCol="0" anchor="ctr"/>
           <a:lstStyle/>
           <a:p>
-            <a:pPr algn="r" indent="0" marL="0">
+            <a:pPr marL="0" indent="0" algn="r">
               <a:buNone/>
             </a:pPr>
             <a:r>
@@ -6633,14 +6458,14 @@
       </p:sp>
       <p:pic>
         <p:nvPicPr>
-          <p:cNvPr id="5" name="Image 0" descr="pulse-faint.png">    </p:cNvPr>
+          <p:cNvPr id="5" name="Image 0" descr="pulse-faint.png"/>
           <p:cNvPicPr>
             <a:picLocks noChangeAspect="1"/>
           </p:cNvPicPr>
           <p:nvPr/>
         </p:nvPicPr>
         <p:blipFill>
-          <a:blip r:embed="rId1"/>
+          <a:blip r:embed="rId3"/>
           <a:stretch>
             <a:fillRect/>
           </a:stretch>
@@ -6671,6 +6496,7 @@
         <a:solidFill>
           <a:srgbClr val="FAF9F7"/>
         </a:solidFill>
+        <a:effectLst/>
       </p:bgPr>
     </p:bg>
     <p:spTree>
@@ -6708,7 +6534,7 @@
           <a:bodyPr wrap="square" rtlCol="0" anchor="ctr"/>
           <a:lstStyle/>
           <a:p>
-            <a:pPr algn="r" indent="0" marL="0">
+            <a:pPr marL="0" indent="0" algn="r">
               <a:buNone/>
             </a:pPr>
             <a:r>
@@ -6796,7 +6622,7 @@
           <a:bodyPr wrap="square" lIns="0" tIns="0" rIns="0" bIns="0" rtlCol="0" anchor="ctr"/>
           <a:lstStyle/>
           <a:p>
-            <a:pPr algn="ctr" indent="0" marL="0">
+            <a:pPr marL="0" indent="0" algn="ctr">
               <a:buNone/>
             </a:pPr>
             <a:r>
@@ -6835,7 +6661,7 @@
           <a:bodyPr wrap="square" lIns="0" tIns="0" rIns="0" bIns="0" rtlCol="0" anchor="ctr"/>
           <a:lstStyle/>
           <a:p>
-            <a:pPr algn="r" indent="0" marL="0">
+            <a:pPr marL="0" indent="0" algn="r" rtl="1">
               <a:buNone/>
             </a:pPr>
             <a:r>
@@ -6923,7 +6749,7 @@
           <a:bodyPr wrap="square" lIns="0" tIns="0" rIns="0" bIns="0" rtlCol="0" anchor="ctr"/>
           <a:lstStyle/>
           <a:p>
-            <a:pPr algn="ctr" indent="0" marL="0">
+            <a:pPr marL="0" indent="0" algn="ctr">
               <a:buNone/>
             </a:pPr>
             <a:r>
@@ -6962,7 +6788,7 @@
           <a:bodyPr wrap="square" lIns="0" tIns="0" rIns="0" bIns="0" rtlCol="0" anchor="ctr"/>
           <a:lstStyle/>
           <a:p>
-            <a:pPr algn="r" indent="0" marL="0">
+            <a:pPr marL="0" indent="0" algn="r" rtl="1">
               <a:buNone/>
             </a:pPr>
             <a:r>
@@ -7050,7 +6876,7 @@
           <a:bodyPr wrap="square" lIns="0" tIns="0" rIns="0" bIns="0" rtlCol="0" anchor="ctr"/>
           <a:lstStyle/>
           <a:p>
-            <a:pPr algn="ctr" indent="0" marL="0">
+            <a:pPr marL="0" indent="0" algn="ctr">
               <a:buNone/>
             </a:pPr>
             <a:r>
@@ -7089,7 +6915,7 @@
           <a:bodyPr wrap="square" lIns="0" tIns="0" rIns="0" bIns="0" rtlCol="0" anchor="ctr"/>
           <a:lstStyle/>
           <a:p>
-            <a:pPr algn="r" indent="0" marL="0">
+            <a:pPr marL="0" indent="0" algn="r" rtl="1">
               <a:buNone/>
             </a:pPr>
             <a:r>
@@ -7177,7 +7003,7 @@
           <a:bodyPr wrap="square" lIns="0" tIns="0" rIns="0" bIns="0" rtlCol="0" anchor="ctr"/>
           <a:lstStyle/>
           <a:p>
-            <a:pPr algn="ctr" indent="0" marL="0">
+            <a:pPr marL="0" indent="0" algn="ctr">
               <a:buNone/>
             </a:pPr>
             <a:r>
@@ -7216,7 +7042,7 @@
           <a:bodyPr wrap="square" lIns="0" tIns="0" rIns="0" bIns="0" rtlCol="0" anchor="ctr"/>
           <a:lstStyle/>
           <a:p>
-            <a:pPr algn="r" indent="0" marL="0">
+            <a:pPr marL="0" indent="0" algn="r" rtl="1">
               <a:buNone/>
             </a:pPr>
             <a:r>
@@ -7250,6 +7076,7 @@
         <a:solidFill>
           <a:srgbClr val="100F0E"/>
         </a:solidFill>
+        <a:effectLst/>
       </p:bgPr>
     </p:bg>
     <p:spTree>
@@ -7287,7 +7114,7 @@
           <a:bodyPr wrap="square" rtlCol="0" anchor="ctr"/>
           <a:lstStyle/>
           <a:p>
-            <a:pPr algn="r" indent="0" marL="0">
+            <a:pPr marL="0" indent="0" algn="r">
               <a:buNone/>
             </a:pPr>
             <a:r>
@@ -7326,7 +7153,7 @@
           <a:bodyPr wrap="square" rtlCol="0" anchor="ctr"/>
           <a:lstStyle/>
           <a:p>
-            <a:pPr algn="r" indent="0" marL="0">
+            <a:pPr marL="0" indent="0" algn="r">
               <a:lnSpc>
                 <a:spcPct val="135000"/>
               </a:lnSpc>
@@ -7346,7 +7173,7 @@
             <a:endParaRPr lang="ar-SA" sz="2200" dirty="0"/>
           </a:p>
           <a:p>
-            <a:pPr algn="r" indent="0" marL="0">
+            <a:pPr marL="0" indent="0" algn="r">
               <a:lnSpc>
                 <a:spcPct val="135000"/>
               </a:lnSpc>
@@ -7388,7 +7215,7 @@
           <a:bodyPr wrap="square" rtlCol="0" anchor="ctr"/>
           <a:lstStyle/>
           <a:p>
-            <a:pPr algn="r" indent="0" marL="0">
+            <a:pPr marL="0" indent="0" algn="r">
               <a:buNone/>
             </a:pPr>
             <a:r>
@@ -7408,14 +7235,14 @@
       </p:sp>
       <p:pic>
         <p:nvPicPr>
-          <p:cNvPr id="5" name="Image 0" descr="pulse-faint.png">    </p:cNvPr>
+          <p:cNvPr id="5" name="Image 0" descr="pulse-faint.png"/>
           <p:cNvPicPr>
             <a:picLocks noChangeAspect="1"/>
           </p:cNvPicPr>
           <p:nvPr/>
         </p:nvPicPr>
         <p:blipFill>
-          <a:blip r:embed="rId1"/>
+          <a:blip r:embed="rId3"/>
           <a:stretch>
             <a:fillRect/>
           </a:stretch>
@@ -7446,6 +7273,7 @@
         <a:solidFill>
           <a:srgbClr val="FAF9F7"/>
         </a:solidFill>
+        <a:effectLst/>
       </p:bgPr>
     </p:bg>
     <p:spTree>
@@ -7483,7 +7311,7 @@
           <a:bodyPr wrap="square" rtlCol="0" anchor="ctr"/>
           <a:lstStyle/>
           <a:p>
-            <a:pPr algn="r" indent="0" marL="0">
+            <a:pPr marL="0" indent="0" algn="r">
               <a:buNone/>
             </a:pPr>
             <a:r>
@@ -7549,7 +7377,7 @@
           <a:bodyPr wrap="square" rtlCol="0" anchor="ctr"/>
           <a:lstStyle/>
           <a:p>
-            <a:pPr algn="r" indent="0" marL="0">
+            <a:pPr marL="0" indent="0" algn="r">
               <a:buNone/>
             </a:pPr>
             <a:r>
@@ -7588,7 +7416,7 @@
           <a:bodyPr wrap="square" rtlCol="0" anchor="t"/>
           <a:lstStyle/>
           <a:p>
-            <a:pPr algn="r" marL="342900" indent="-342900">
+            <a:pPr marL="342900" indent="-342900" algn="r" rtl="1">
               <a:spcAft>
                 <a:spcPts val="500"/>
               </a:spcAft>
@@ -7609,7 +7437,7 @@
             <a:endParaRPr lang="ar-SA" sz="1200" dirty="0"/>
           </a:p>
           <a:p>
-            <a:pPr algn="r" marL="342900" indent="-342900">
+            <a:pPr marL="342900" indent="-342900" algn="r" rtl="1">
               <a:spcAft>
                 <a:spcPts val="500"/>
               </a:spcAft>
@@ -7630,7 +7458,7 @@
             <a:endParaRPr lang="ar-SA" sz="1200" dirty="0"/>
           </a:p>
           <a:p>
-            <a:pPr algn="r" marL="342900" indent="-342900">
+            <a:pPr marL="342900" indent="-342900" algn="r" rtl="1">
               <a:spcAft>
                 <a:spcPts val="500"/>
               </a:spcAft>
@@ -7651,7 +7479,7 @@
             <a:endParaRPr lang="ar-SA" sz="1200" dirty="0"/>
           </a:p>
           <a:p>
-            <a:pPr algn="r" marL="342900" indent="-342900">
+            <a:pPr marL="342900" indent="-342900" algn="r" rtl="1">
               <a:spcAft>
                 <a:spcPts val="500"/>
               </a:spcAft>
@@ -7721,7 +7549,7 @@
           <a:bodyPr wrap="square" rtlCol="0" anchor="ctr"/>
           <a:lstStyle/>
           <a:p>
-            <a:pPr algn="r" indent="0" marL="0">
+            <a:pPr marL="0" indent="0" algn="r">
               <a:buNone/>
             </a:pPr>
             <a:r>
@@ -7760,7 +7588,7 @@
           <a:bodyPr wrap="square" rtlCol="0" anchor="t"/>
           <a:lstStyle/>
           <a:p>
-            <a:pPr algn="r" marL="342900" indent="-342900">
+            <a:pPr marL="342900" indent="-342900" algn="r" rtl="1">
               <a:spcAft>
                 <a:spcPts val="500"/>
               </a:spcAft>
@@ -7781,7 +7609,7 @@
             <a:endParaRPr lang="ar-SA" sz="1200" dirty="0"/>
           </a:p>
           <a:p>
-            <a:pPr algn="r" marL="342900" indent="-342900">
+            <a:pPr marL="342900" indent="-342900" algn="r" rtl="1">
               <a:spcAft>
                 <a:spcPts val="500"/>
               </a:spcAft>
@@ -7802,7 +7630,7 @@
             <a:endParaRPr lang="ar-SA" sz="1200" dirty="0"/>
           </a:p>
           <a:p>
-            <a:pPr algn="r" marL="342900" indent="-342900">
+            <a:pPr marL="342900" indent="-342900" algn="r" rtl="1">
               <a:spcAft>
                 <a:spcPts val="500"/>
               </a:spcAft>
@@ -7823,7 +7651,7 @@
             <a:endParaRPr lang="ar-SA" sz="1200" dirty="0"/>
           </a:p>
           <a:p>
-            <a:pPr algn="r" marL="342900" indent="-342900">
+            <a:pPr marL="342900" indent="-342900" algn="r" rtl="1">
               <a:spcAft>
                 <a:spcPts val="500"/>
               </a:spcAft>
@@ -7893,7 +7721,7 @@
           <a:bodyPr wrap="square" rtlCol="0" anchor="ctr"/>
           <a:lstStyle/>
           <a:p>
-            <a:pPr algn="r" indent="0" marL="0">
+            <a:pPr marL="0" indent="0" algn="r">
               <a:buNone/>
             </a:pPr>
             <a:r>
@@ -7932,7 +7760,7 @@
           <a:bodyPr wrap="square" rtlCol="0" anchor="t"/>
           <a:lstStyle/>
           <a:p>
-            <a:pPr algn="r" marL="342900" indent="-342900">
+            <a:pPr marL="342900" indent="-342900" algn="r" rtl="1">
               <a:spcAft>
                 <a:spcPts val="500"/>
               </a:spcAft>
@@ -7953,7 +7781,7 @@
             <a:endParaRPr lang="ar-SA" sz="1200" dirty="0"/>
           </a:p>
           <a:p>
-            <a:pPr algn="r" marL="342900" indent="-342900">
+            <a:pPr marL="342900" indent="-342900" algn="r" rtl="1">
               <a:spcAft>
                 <a:spcPts val="500"/>
               </a:spcAft>
@@ -7974,7 +7802,7 @@
             <a:endParaRPr lang="ar-SA" sz="1200" dirty="0"/>
           </a:p>
           <a:p>
-            <a:pPr algn="r" marL="342900" indent="-342900">
+            <a:pPr marL="342900" indent="-342900" algn="r" rtl="1">
               <a:spcAft>
                 <a:spcPts val="500"/>
               </a:spcAft>
@@ -7995,7 +7823,7 @@
             <a:endParaRPr lang="ar-SA" sz="1200" dirty="0"/>
           </a:p>
           <a:p>
-            <a:pPr algn="r" marL="342900" indent="-342900">
+            <a:pPr marL="342900" indent="-342900" algn="r" rtl="1">
               <a:spcAft>
                 <a:spcPts val="500"/>
               </a:spcAft>
@@ -8065,7 +7893,7 @@
           <a:bodyPr wrap="square" rtlCol="0" anchor="ctr"/>
           <a:lstStyle/>
           <a:p>
-            <a:pPr algn="r" indent="0" marL="0">
+            <a:pPr marL="0" indent="0" algn="r">
               <a:buNone/>
             </a:pPr>
             <a:r>
@@ -8104,7 +7932,7 @@
           <a:bodyPr wrap="square" rtlCol="0" anchor="t"/>
           <a:lstStyle/>
           <a:p>
-            <a:pPr algn="r" marL="342900" indent="-342900">
+            <a:pPr marL="342900" indent="-342900" algn="r" rtl="1">
               <a:spcAft>
                 <a:spcPts val="500"/>
               </a:spcAft>
@@ -8125,7 +7953,7 @@
             <a:endParaRPr lang="ar-SA" sz="1200" dirty="0"/>
           </a:p>
           <a:p>
-            <a:pPr algn="r" marL="342900" indent="-342900">
+            <a:pPr marL="342900" indent="-342900" algn="r" rtl="1">
               <a:spcAft>
                 <a:spcPts val="500"/>
               </a:spcAft>
@@ -8146,7 +7974,7 @@
             <a:endParaRPr lang="ar-SA" sz="1200" dirty="0"/>
           </a:p>
           <a:p>
-            <a:pPr algn="r" marL="342900" indent="-342900">
+            <a:pPr marL="342900" indent="-342900" algn="r" rtl="1">
               <a:spcAft>
                 <a:spcPts val="500"/>
               </a:spcAft>
@@ -8167,7 +7995,7 @@
             <a:endParaRPr lang="ar-SA" sz="1200" dirty="0"/>
           </a:p>
           <a:p>
-            <a:pPr algn="r" marL="342900" indent="-342900">
+            <a:pPr marL="342900" indent="-342900" algn="r" rtl="1">
               <a:spcAft>
                 <a:spcPts val="500"/>
               </a:spcAft>
@@ -8205,6 +8033,7 @@
         <a:solidFill>
           <a:srgbClr val="100F0E"/>
         </a:solidFill>
+        <a:effectLst/>
       </p:bgPr>
     </p:bg>
     <p:spTree>
@@ -8223,14 +8052,14 @@
       </p:grpSpPr>
       <p:pic>
         <p:nvPicPr>
-          <p:cNvPr id="2" name="Image 0" descr="pulse-periwinkle.png">    </p:cNvPr>
+          <p:cNvPr id="2" name="Image 0" descr="pulse-periwinkle.png"/>
           <p:cNvPicPr>
             <a:picLocks noChangeAspect="1"/>
           </p:cNvPicPr>
           <p:nvPr/>
         </p:nvPicPr>
         <p:blipFill>
-          <a:blip r:embed="rId1"/>
+          <a:blip r:embed="rId3"/>
           <a:stretch>
             <a:fillRect/>
           </a:stretch>
@@ -8266,7 +8095,7 @@
           <a:bodyPr wrap="square" rtlCol="0" anchor="ctr"/>
           <a:lstStyle/>
           <a:p>
-            <a:pPr algn="ctr" indent="0" marL="0">
+            <a:pPr marL="0" indent="0" algn="ctr">
               <a:buNone/>
             </a:pPr>
             <a:r>
@@ -8305,7 +8134,7 @@
           <a:bodyPr wrap="square" rtlCol="0" anchor="ctr"/>
           <a:lstStyle/>
           <a:p>
-            <a:pPr algn="ctr" indent="0" marL="0">
+            <a:pPr marL="0" indent="0" algn="ctr" rtl="1">
               <a:buNone/>
             </a:pPr>
             <a:r>
@@ -8344,7 +8173,7 @@
           <a:bodyPr wrap="square" rtlCol="0" anchor="ctr"/>
           <a:lstStyle/>
           <a:p>
-            <a:pPr algn="ctr" indent="0" marL="0">
+            <a:pPr marL="0" indent="0" algn="ctr" rtl="1">
               <a:buNone/>
             </a:pPr>
             <a:r>
@@ -8383,7 +8212,7 @@
           <a:bodyPr wrap="square" rtlCol="0" anchor="ctr"/>
           <a:lstStyle/>
           <a:p>
-            <a:pPr algn="ctr" indent="0" marL="0">
+            <a:pPr marL="0" indent="0" algn="ctr">
               <a:buNone/>
             </a:pPr>
             <a:r>
@@ -8417,6 +8246,7 @@
         <a:solidFill>
           <a:srgbClr val="100F0E"/>
         </a:solidFill>
+        <a:effectLst/>
       </p:bgPr>
     </p:bg>
     <p:spTree>
@@ -8454,7 +8284,7 @@
           <a:bodyPr wrap="square" rtlCol="0" anchor="ctr"/>
           <a:lstStyle/>
           <a:p>
-            <a:pPr algn="l" indent="0" marL="0">
+            <a:pPr marL="0" indent="0" algn="l">
               <a:buNone/>
             </a:pPr>
             <a:r>
@@ -8493,7 +8323,7 @@
           <a:bodyPr wrap="square" rtlCol="0" anchor="ctr"/>
           <a:lstStyle/>
           <a:p>
-            <a:pPr algn="r" indent="0" marL="0">
+            <a:pPr marL="0" indent="0" algn="r">
               <a:buNone/>
             </a:pPr>
             <a:r>
@@ -8532,7 +8362,7 @@
           <a:bodyPr wrap="square" rtlCol="0" anchor="ctr"/>
           <a:lstStyle/>
           <a:p>
-            <a:pPr algn="r" indent="0" marL="0">
+            <a:pPr marL="0" indent="0" algn="r">
               <a:buNone/>
             </a:pPr>
             <a:r>
@@ -8552,14 +8382,14 @@
       </p:sp>
       <p:pic>
         <p:nvPicPr>
-          <p:cNvPr id="5" name="Image 0" descr="pulse-faint.png">    </p:cNvPr>
+          <p:cNvPr id="5" name="Image 0" descr="pulse-faint.png"/>
           <p:cNvPicPr>
             <a:picLocks noChangeAspect="1"/>
           </p:cNvPicPr>
           <p:nvPr/>
         </p:nvPicPr>
         <p:blipFill>
-          <a:blip r:embed="rId1"/>
+          <a:blip r:embed="rId3"/>
           <a:stretch>
             <a:fillRect/>
           </a:stretch>
@@ -8590,6 +8420,7 @@
         <a:solidFill>
           <a:srgbClr val="FAF9F7"/>
         </a:solidFill>
+        <a:effectLst/>
       </p:bgPr>
     </p:bg>
     <p:spTree>
@@ -8627,7 +8458,7 @@
           <a:bodyPr wrap="square" rtlCol="0" anchor="ctr"/>
           <a:lstStyle/>
           <a:p>
-            <a:pPr algn="r" indent="0" marL="0">
+            <a:pPr marL="0" indent="0" algn="r">
               <a:buNone/>
             </a:pPr>
             <a:r>
@@ -8699,14 +8530,14 @@
       </p:sp>
       <p:pic>
         <p:nvPicPr>
-          <p:cNvPr id="5" name="Image 0" descr="ic-clock.png">    </p:cNvPr>
+          <p:cNvPr id="5" name="Image 0" descr="ic-clock.png"/>
           <p:cNvPicPr>
             <a:picLocks noChangeAspect="1"/>
           </p:cNvPicPr>
           <p:nvPr/>
         </p:nvPicPr>
         <p:blipFill>
-          <a:blip r:embed="rId1"/>
+          <a:blip r:embed="rId3"/>
           <a:stretch>
             <a:fillRect/>
           </a:stretch>
@@ -8742,7 +8573,7 @@
           <a:bodyPr wrap="square" lIns="0" tIns="0" rIns="0" bIns="0" rtlCol="0" anchor="ctr"/>
           <a:lstStyle/>
           <a:p>
-            <a:pPr algn="r" indent="0" marL="0">
+            <a:pPr marL="0" indent="0" algn="r">
               <a:buNone/>
             </a:pPr>
             <a:r>
@@ -8781,7 +8612,7 @@
           <a:bodyPr wrap="square" lIns="0" tIns="0" rIns="0" bIns="0" rtlCol="0" anchor="t"/>
           <a:lstStyle/>
           <a:p>
-            <a:pPr algn="r" indent="0" marL="0">
+            <a:pPr marL="0" indent="0" algn="r">
               <a:buNone/>
             </a:pPr>
             <a:r>
@@ -8853,14 +8684,14 @@
       </p:sp>
       <p:pic>
         <p:nvPicPr>
-          <p:cNvPr id="10" name="Image 1" descr="ic-mic.png">    </p:cNvPr>
+          <p:cNvPr id="10" name="Image 1" descr="ic-mic.png"/>
           <p:cNvPicPr>
             <a:picLocks noChangeAspect="1"/>
           </p:cNvPicPr>
           <p:nvPr/>
         </p:nvPicPr>
         <p:blipFill>
-          <a:blip r:embed="rId2"/>
+          <a:blip r:embed="rId4"/>
           <a:stretch>
             <a:fillRect/>
           </a:stretch>
@@ -8896,7 +8727,7 @@
           <a:bodyPr wrap="square" lIns="0" tIns="0" rIns="0" bIns="0" rtlCol="0" anchor="ctr"/>
           <a:lstStyle/>
           <a:p>
-            <a:pPr algn="r" indent="0" marL="0">
+            <a:pPr marL="0" indent="0" algn="r">
               <a:buNone/>
             </a:pPr>
             <a:r>
@@ -8935,7 +8766,7 @@
           <a:bodyPr wrap="square" lIns="0" tIns="0" rIns="0" bIns="0" rtlCol="0" anchor="t"/>
           <a:lstStyle/>
           <a:p>
-            <a:pPr algn="r" indent="0" marL="0">
+            <a:pPr marL="0" indent="0" algn="r">
               <a:buNone/>
             </a:pPr>
             <a:r>
@@ -9007,14 +8838,14 @@
       </p:sp>
       <p:pic>
         <p:nvPicPr>
-          <p:cNvPr id="15" name="Image 2" descr="ic-cross.png">    </p:cNvPr>
+          <p:cNvPr id="15" name="Image 2" descr="ic-cross.png"/>
           <p:cNvPicPr>
             <a:picLocks noChangeAspect="1"/>
           </p:cNvPicPr>
           <p:nvPr/>
         </p:nvPicPr>
         <p:blipFill>
-          <a:blip r:embed="rId3"/>
+          <a:blip r:embed="rId5"/>
           <a:stretch>
             <a:fillRect/>
           </a:stretch>
@@ -9050,7 +8881,7 @@
           <a:bodyPr wrap="square" lIns="0" tIns="0" rIns="0" bIns="0" rtlCol="0" anchor="ctr"/>
           <a:lstStyle/>
           <a:p>
-            <a:pPr algn="r" indent="0" marL="0">
+            <a:pPr marL="0" indent="0" algn="r">
               <a:buNone/>
             </a:pPr>
             <a:r>
@@ -9089,7 +8920,7 @@
           <a:bodyPr wrap="square" lIns="0" tIns="0" rIns="0" bIns="0" rtlCol="0" anchor="t"/>
           <a:lstStyle/>
           <a:p>
-            <a:pPr algn="r" indent="0" marL="0">
+            <a:pPr marL="0" indent="0" algn="r">
               <a:buNone/>
             </a:pPr>
             <a:r>
@@ -9123,6 +8954,7 @@
         <a:solidFill>
           <a:srgbClr val="FAF9F7"/>
         </a:solidFill>
+        <a:effectLst/>
       </p:bgPr>
     </p:bg>
     <p:spTree>
@@ -9160,7 +8992,7 @@
           <a:bodyPr wrap="square" rtlCol="0" anchor="ctr"/>
           <a:lstStyle/>
           <a:p>
-            <a:pPr algn="r" indent="0" marL="0">
+            <a:pPr marL="0" indent="0" algn="r">
               <a:buNone/>
             </a:pPr>
             <a:r>
@@ -9232,14 +9064,14 @@
       </p:sp>
       <p:pic>
         <p:nvPicPr>
-          <p:cNvPr id="5" name="Image 0" descr="ic-users.png">    </p:cNvPr>
+          <p:cNvPr id="5" name="Image 0" descr="ic-users.png"/>
           <p:cNvPicPr>
             <a:picLocks noChangeAspect="1"/>
           </p:cNvPicPr>
           <p:nvPr/>
         </p:nvPicPr>
         <p:blipFill>
-          <a:blip r:embed="rId1"/>
+          <a:blip r:embed="rId3"/>
           <a:stretch>
             <a:fillRect/>
           </a:stretch>
@@ -9275,7 +9107,7 @@
           <a:bodyPr wrap="square" lIns="0" tIns="0" rIns="0" bIns="0" rtlCol="0" anchor="ctr"/>
           <a:lstStyle/>
           <a:p>
-            <a:pPr algn="r" indent="0" marL="0">
+            <a:pPr marL="0" indent="0" algn="r">
               <a:buNone/>
             </a:pPr>
             <a:r>
@@ -9314,7 +9146,7 @@
           <a:bodyPr wrap="square" lIns="0" tIns="0" rIns="0" bIns="0" rtlCol="0" anchor="t"/>
           <a:lstStyle/>
           <a:p>
-            <a:pPr algn="r" indent="0" marL="0">
+            <a:pPr marL="0" indent="0" algn="r">
               <a:buNone/>
             </a:pPr>
             <a:r>
@@ -9386,14 +9218,14 @@
       </p:sp>
       <p:pic>
         <p:nvPicPr>
-          <p:cNvPr id="10" name="Image 1" descr="ic-building.png">    </p:cNvPr>
+          <p:cNvPr id="10" name="Image 1" descr="ic-building.png"/>
           <p:cNvPicPr>
             <a:picLocks noChangeAspect="1"/>
           </p:cNvPicPr>
           <p:nvPr/>
         </p:nvPicPr>
         <p:blipFill>
-          <a:blip r:embed="rId2"/>
+          <a:blip r:embed="rId4"/>
           <a:stretch>
             <a:fillRect/>
           </a:stretch>
@@ -9429,7 +9261,7 @@
           <a:bodyPr wrap="square" lIns="0" tIns="0" rIns="0" bIns="0" rtlCol="0" anchor="ctr"/>
           <a:lstStyle/>
           <a:p>
-            <a:pPr algn="r" indent="0" marL="0">
+            <a:pPr marL="0" indent="0" algn="r">
               <a:buNone/>
             </a:pPr>
             <a:r>
@@ -9468,7 +9300,7 @@
           <a:bodyPr wrap="square" lIns="0" tIns="0" rIns="0" bIns="0" rtlCol="0" anchor="t"/>
           <a:lstStyle/>
           <a:p>
-            <a:pPr algn="r" indent="0" marL="0">
+            <a:pPr marL="0" indent="0" algn="r">
               <a:buNone/>
             </a:pPr>
             <a:r>
@@ -9540,14 +9372,14 @@
       </p:sp>
       <p:pic>
         <p:nvPicPr>
-          <p:cNvPr id="15" name="Image 2" descr="ic-heart.png">    </p:cNvPr>
+          <p:cNvPr id="15" name="Image 2" descr="ic-heart.png"/>
           <p:cNvPicPr>
             <a:picLocks noChangeAspect="1"/>
           </p:cNvPicPr>
           <p:nvPr/>
         </p:nvPicPr>
         <p:blipFill>
-          <a:blip r:embed="rId3"/>
+          <a:blip r:embed="rId5"/>
           <a:stretch>
             <a:fillRect/>
           </a:stretch>
@@ -9583,7 +9415,7 @@
           <a:bodyPr wrap="square" lIns="0" tIns="0" rIns="0" bIns="0" rtlCol="0" anchor="ctr"/>
           <a:lstStyle/>
           <a:p>
-            <a:pPr algn="r" indent="0" marL="0">
+            <a:pPr marL="0" indent="0" algn="r">
               <a:buNone/>
             </a:pPr>
             <a:r>
@@ -9622,7 +9454,7 @@
           <a:bodyPr wrap="square" lIns="0" tIns="0" rIns="0" bIns="0" rtlCol="0" anchor="t"/>
           <a:lstStyle/>
           <a:p>
-            <a:pPr algn="r" indent="0" marL="0">
+            <a:pPr marL="0" indent="0" algn="r">
               <a:buNone/>
             </a:pPr>
             <a:r>
@@ -9656,6 +9488,7 @@
         <a:solidFill>
           <a:srgbClr val="100F0E"/>
         </a:solidFill>
+        <a:effectLst/>
       </p:bgPr>
     </p:bg>
     <p:spTree>
@@ -9693,7 +9526,7 @@
           <a:bodyPr wrap="square" rtlCol="0" anchor="ctr"/>
           <a:lstStyle/>
           <a:p>
-            <a:pPr algn="l" indent="0" marL="0">
+            <a:pPr marL="0" indent="0" algn="l">
               <a:buNone/>
             </a:pPr>
             <a:r>
@@ -9732,7 +9565,7 @@
           <a:bodyPr wrap="square" rtlCol="0" anchor="ctr"/>
           <a:lstStyle/>
           <a:p>
-            <a:pPr algn="r" indent="0" marL="0">
+            <a:pPr marL="0" indent="0" algn="r">
               <a:buNone/>
             </a:pPr>
             <a:r>
@@ -9771,7 +9604,7 @@
           <a:bodyPr wrap="square" rtlCol="0" anchor="ctr"/>
           <a:lstStyle/>
           <a:p>
-            <a:pPr algn="r" indent="0" marL="0">
+            <a:pPr marL="0" indent="0" algn="r">
               <a:buNone/>
             </a:pPr>
             <a:r>
@@ -9791,14 +9624,14 @@
       </p:sp>
       <p:pic>
         <p:nvPicPr>
-          <p:cNvPr id="5" name="Image 0" descr="pulse-faint.png">    </p:cNvPr>
+          <p:cNvPr id="5" name="Image 0" descr="pulse-faint.png"/>
           <p:cNvPicPr>
             <a:picLocks noChangeAspect="1"/>
           </p:cNvPicPr>
           <p:nvPr/>
         </p:nvPicPr>
         <p:blipFill>
-          <a:blip r:embed="rId1"/>
+          <a:blip r:embed="rId3"/>
           <a:stretch>
             <a:fillRect/>
           </a:stretch>
@@ -9829,6 +9662,7 @@
         <a:solidFill>
           <a:srgbClr val="FAF9F7"/>
         </a:solidFill>
+        <a:effectLst/>
       </p:bgPr>
     </p:bg>
     <p:spTree>
@@ -9866,7 +9700,7 @@
           <a:bodyPr wrap="square" rtlCol="0" anchor="ctr"/>
           <a:lstStyle/>
           <a:p>
-            <a:pPr algn="r" indent="0" marL="0">
+            <a:pPr marL="0" indent="0" algn="r">
               <a:buNone/>
             </a:pPr>
             <a:r>
@@ -9938,14 +9772,14 @@
       </p:sp>
       <p:pic>
         <p:nvPicPr>
-          <p:cNvPr id="5" name="Image 0" descr="ic-cross.png">    </p:cNvPr>
+          <p:cNvPr id="5" name="Image 0" descr="ic-cross.png"/>
           <p:cNvPicPr>
             <a:picLocks noChangeAspect="1"/>
           </p:cNvPicPr>
           <p:nvPr/>
         </p:nvPicPr>
         <p:blipFill>
-          <a:blip r:embed="rId1"/>
+          <a:blip r:embed="rId3"/>
           <a:stretch>
             <a:fillRect/>
           </a:stretch>
@@ -9981,7 +9815,7 @@
           <a:bodyPr wrap="square" rtlCol="0" anchor="ctr"/>
           <a:lstStyle/>
           <a:p>
-            <a:pPr algn="ctr" indent="0" marL="0">
+            <a:pPr marL="0" indent="0" algn="ctr">
               <a:buNone/>
             </a:pPr>
             <a:r>
@@ -10020,7 +9854,7 @@
           <a:bodyPr wrap="square" rtlCol="0" anchor="ctr"/>
           <a:lstStyle/>
           <a:p>
-            <a:pPr algn="ctr" indent="0" marL="0">
+            <a:pPr marL="0" indent="0" algn="ctr">
               <a:buNone/>
             </a:pPr>
             <a:r>
@@ -10059,7 +9893,7 @@
           <a:bodyPr wrap="square" rtlCol="0" anchor="t"/>
           <a:lstStyle/>
           <a:p>
-            <a:pPr algn="ctr" indent="0" marL="0">
+            <a:pPr marL="0" indent="0" algn="ctr">
               <a:buNone/>
             </a:pPr>
             <a:r>
@@ -10131,14 +9965,14 @@
       </p:sp>
       <p:pic>
         <p:nvPicPr>
-          <p:cNvPr id="11" name="Image 1" descr="ic-heart.png">    </p:cNvPr>
+          <p:cNvPr id="11" name="Image 1" descr="ic-heart.png"/>
           <p:cNvPicPr>
             <a:picLocks noChangeAspect="1"/>
           </p:cNvPicPr>
           <p:nvPr/>
         </p:nvPicPr>
         <p:blipFill>
-          <a:blip r:embed="rId2"/>
+          <a:blip r:embed="rId4"/>
           <a:stretch>
             <a:fillRect/>
           </a:stretch>
@@ -10174,7 +10008,7 @@
           <a:bodyPr wrap="square" rtlCol="0" anchor="ctr"/>
           <a:lstStyle/>
           <a:p>
-            <a:pPr algn="ctr" indent="0" marL="0">
+            <a:pPr marL="0" indent="0" algn="ctr">
               <a:buNone/>
             </a:pPr>
             <a:r>
@@ -10213,7 +10047,7 @@
           <a:bodyPr wrap="square" rtlCol="0" anchor="ctr"/>
           <a:lstStyle/>
           <a:p>
-            <a:pPr algn="ctr" indent="0" marL="0">
+            <a:pPr marL="0" indent="0" algn="ctr">
               <a:buNone/>
             </a:pPr>
             <a:r>
@@ -10252,7 +10086,7 @@
           <a:bodyPr wrap="square" rtlCol="0" anchor="t"/>
           <a:lstStyle/>
           <a:p>
-            <a:pPr algn="ctr" indent="0" marL="0">
+            <a:pPr marL="0" indent="0" algn="ctr">
               <a:buNone/>
             </a:pPr>
             <a:r>
@@ -10324,14 +10158,14 @@
       </p:sp>
       <p:pic>
         <p:nvPicPr>
-          <p:cNvPr id="17" name="Image 2" descr="ic-building.png">    </p:cNvPr>
+          <p:cNvPr id="17" name="Image 2" descr="ic-building.png"/>
           <p:cNvPicPr>
             <a:picLocks noChangeAspect="1"/>
           </p:cNvPicPr>
           <p:nvPr/>
         </p:nvPicPr>
         <p:blipFill>
-          <a:blip r:embed="rId3"/>
+          <a:blip r:embed="rId5"/>
           <a:stretch>
             <a:fillRect/>
           </a:stretch>
@@ -10367,7 +10201,7 @@
           <a:bodyPr wrap="square" rtlCol="0" anchor="ctr"/>
           <a:lstStyle/>
           <a:p>
-            <a:pPr algn="ctr" indent="0" marL="0">
+            <a:pPr marL="0" indent="0" algn="ctr">
               <a:buNone/>
             </a:pPr>
             <a:r>
@@ -10406,7 +10240,7 @@
           <a:bodyPr wrap="square" rtlCol="0" anchor="ctr"/>
           <a:lstStyle/>
           <a:p>
-            <a:pPr algn="ctr" indent="0" marL="0">
+            <a:pPr marL="0" indent="0" algn="ctr">
               <a:buNone/>
             </a:pPr>
             <a:r>
@@ -10445,7 +10279,7 @@
           <a:bodyPr wrap="square" rtlCol="0" anchor="t"/>
           <a:lstStyle/>
           <a:p>
-            <a:pPr algn="ctr" indent="0" marL="0">
+            <a:pPr marL="0" indent="0" algn="ctr">
               <a:buNone/>
             </a:pPr>
             <a:r>
@@ -10484,7 +10318,7 @@
           <a:bodyPr wrap="square" rtlCol="0" anchor="ctr"/>
           <a:lstStyle/>
           <a:p>
-            <a:pPr algn="ctr" indent="0" marL="0">
+            <a:pPr marL="0" indent="0" algn="ctr">
               <a:buNone/>
             </a:pPr>
             <a:r>
@@ -10518,6 +10352,7 @@
         <a:solidFill>
           <a:srgbClr val="100F0E"/>
         </a:solidFill>
+        <a:effectLst/>
       </p:bgPr>
     </p:bg>
     <p:spTree>
@@ -10555,7 +10390,7 @@
           <a:bodyPr wrap="square" rtlCol="0" anchor="ctr"/>
           <a:lstStyle/>
           <a:p>
-            <a:pPr algn="r" indent="0" marL="0">
+            <a:pPr marL="0" indent="0" algn="r">
               <a:buNone/>
             </a:pPr>
             <a:r>
@@ -10575,14 +10410,14 @@
       </p:sp>
       <p:pic>
         <p:nvPicPr>
-          <p:cNvPr id="3" name="Image 0" descr="shots/c-03-ward-list.png">    </p:cNvPr>
+          <p:cNvPr id="3" name="Image 0" descr="shots/c-03-ward-list.png"/>
           <p:cNvPicPr>
             <a:picLocks noChangeAspect="1"/>
           </p:cNvPicPr>
           <p:nvPr/>
         </p:nvPicPr>
         <p:blipFill>
-          <a:blip r:embed="rId1"/>
+          <a:blip r:embed="rId3"/>
           <a:stretch>
             <a:fillRect/>
           </a:stretch>
@@ -10599,14 +10434,14 @@
       </p:pic>
       <p:pic>
         <p:nvPicPr>
-          <p:cNvPr id="4" name="Image 1" descr="shots/c-04-draft-review.png">    </p:cNvPr>
+          <p:cNvPr id="4" name="Image 1" descr="shots/c-04-draft-review.png"/>
           <p:cNvPicPr>
             <a:picLocks noChangeAspect="1"/>
           </p:cNvPicPr>
           <p:nvPr/>
         </p:nvPicPr>
         <p:blipFill>
-          <a:blip r:embed="rId2"/>
+          <a:blip r:embed="rId4"/>
           <a:stretch>
             <a:fillRect/>
           </a:stretch>
@@ -10667,7 +10502,7 @@
           <a:bodyPr wrap="square" lIns="0" tIns="0" rIns="0" bIns="0" rtlCol="0" anchor="ctr"/>
           <a:lstStyle/>
           <a:p>
-            <a:pPr algn="ctr" indent="0" marL="0">
+            <a:pPr marL="0" indent="0" algn="ctr">
               <a:buNone/>
             </a:pPr>
             <a:r>
@@ -10703,7 +10538,7 @@
           <a:bodyPr wrap="square" rtlCol="0" anchor="ctr"/>
           <a:lstStyle/>
           <a:p>
-            <a:pPr algn="r" indent="0" marL="0">
+            <a:pPr marL="0" indent="0" algn="r">
               <a:buNone/>
             </a:pPr>
             <a:r>
@@ -10748,14 +10583,14 @@
       </p:sp>
       <p:pic>
         <p:nvPicPr>
-          <p:cNvPr id="9" name="Image 2" descr="ic-mic.png">    </p:cNvPr>
+          <p:cNvPr id="9" name="Image 2" descr="ic-mic.png"/>
           <p:cNvPicPr>
             <a:picLocks noChangeAspect="1"/>
           </p:cNvPicPr>
           <p:nvPr/>
         </p:nvPicPr>
         <p:blipFill>
-          <a:blip r:embed="rId3"/>
+          <a:blip r:embed="rId5"/>
           <a:stretch>
             <a:fillRect/>
           </a:stretch>
@@ -10791,7 +10626,7 @@
           <a:bodyPr wrap="square" rtlCol="0" anchor="ctr"/>
           <a:lstStyle/>
           <a:p>
-            <a:pPr algn="r" indent="0" marL="0">
+            <a:pPr marL="0" indent="0" algn="r">
               <a:buNone/>
             </a:pPr>
             <a:r>
@@ -10836,14 +10671,14 @@
       </p:sp>
       <p:pic>
         <p:nvPicPr>
-          <p:cNvPr id="12" name="Image 3" descr="ic-check.png">    </p:cNvPr>
+          <p:cNvPr id="12" name="Image 3" descr="ic-check.png"/>
           <p:cNvPicPr>
             <a:picLocks noChangeAspect="1"/>
           </p:cNvPicPr>
           <p:nvPr/>
         </p:nvPicPr>
         <p:blipFill>
-          <a:blip r:embed="rId4"/>
+          <a:blip r:embed="rId6"/>
           <a:stretch>
             <a:fillRect/>
           </a:stretch>
@@ -10879,7 +10714,7 @@
           <a:bodyPr wrap="square" rtlCol="0" anchor="ctr"/>
           <a:lstStyle/>
           <a:p>
-            <a:pPr algn="r" indent="0" marL="0">
+            <a:pPr marL="0" indent="0" algn="r">
               <a:buNone/>
             </a:pPr>
             <a:r>
@@ -10913,6 +10748,7 @@
         <a:solidFill>
           <a:srgbClr val="100F0E"/>
         </a:solidFill>
+        <a:effectLst/>
       </p:bgPr>
     </p:bg>
     <p:spTree>
@@ -10950,7 +10786,7 @@
           <a:bodyPr wrap="square" rtlCol="0" anchor="ctr"/>
           <a:lstStyle/>
           <a:p>
-            <a:pPr algn="r" indent="0" marL="0">
+            <a:pPr marL="0" indent="0" algn="r">
               <a:buNone/>
             </a:pPr>
             <a:r>
@@ -10970,14 +10806,14 @@
       </p:sp>
       <p:pic>
         <p:nvPicPr>
-          <p:cNvPr id="3" name="Image 0" descr="shots/c-05-confirm-chip.png">    </p:cNvPr>
+          <p:cNvPr id="3" name="Image 0" descr="shots/c-05-confirm-chip.png"/>
           <p:cNvPicPr>
             <a:picLocks noChangeAspect="1"/>
           </p:cNvPicPr>
           <p:nvPr/>
         </p:nvPicPr>
         <p:blipFill>
-          <a:blip r:embed="rId1"/>
+          <a:blip r:embed="rId3"/>
           <a:stretch>
             <a:fillRect/>
           </a:stretch>
@@ -10994,14 +10830,14 @@
       </p:pic>
       <p:pic>
         <p:nvPicPr>
-          <p:cNvPr id="4" name="Image 1" descr="shots/c-06-sign-sheet.png">    </p:cNvPr>
+          <p:cNvPr id="4" name="Image 1" descr="shots/c-06-sign-sheet.png"/>
           <p:cNvPicPr>
             <a:picLocks noChangeAspect="1"/>
           </p:cNvPicPr>
           <p:nvPr/>
         </p:nvPicPr>
         <p:blipFill>
-          <a:blip r:embed="rId2"/>
+          <a:blip r:embed="rId4"/>
           <a:stretch>
             <a:fillRect/>
           </a:stretch>
@@ -11043,14 +10879,14 @@
       </p:sp>
       <p:pic>
         <p:nvPicPr>
-          <p:cNvPr id="6" name="Image 2" descr="ic-shield.png">    </p:cNvPr>
+          <p:cNvPr id="6" name="Image 2" descr="ic-shield.png"/>
           <p:cNvPicPr>
             <a:picLocks noChangeAspect="1"/>
           </p:cNvPicPr>
           <p:nvPr/>
         </p:nvPicPr>
         <p:blipFill>
-          <a:blip r:embed="rId3"/>
+          <a:blip r:embed="rId5"/>
           <a:stretch>
             <a:fillRect/>
           </a:stretch>
@@ -11086,7 +10922,7 @@
           <a:bodyPr wrap="square" rtlCol="0" anchor="ctr"/>
           <a:lstStyle/>
           <a:p>
-            <a:pPr algn="r" indent="0" marL="0">
+            <a:pPr marL="0" indent="0" algn="r">
               <a:buNone/>
             </a:pPr>
             <a:r>
@@ -11131,14 +10967,14 @@
       </p:sp>
       <p:pic>
         <p:nvPicPr>
-          <p:cNvPr id="9" name="Image 3" descr="ic-zap.png">    </p:cNvPr>
+          <p:cNvPr id="9" name="Image 3" descr="ic-zap.png"/>
           <p:cNvPicPr>
             <a:picLocks noChangeAspect="1"/>
           </p:cNvPicPr>
           <p:nvPr/>
         </p:nvPicPr>
         <p:blipFill>
-          <a:blip r:embed="rId4"/>
+          <a:blip r:embed="rId6"/>
           <a:stretch>
             <a:fillRect/>
           </a:stretch>
@@ -11174,7 +11010,7 @@
           <a:bodyPr wrap="square" rtlCol="0" anchor="ctr"/>
           <a:lstStyle/>
           <a:p>
-            <a:pPr algn="r" indent="0" marL="0">
+            <a:pPr marL="0" indent="0" algn="r" rtl="1">
               <a:buNone/>
             </a:pPr>
             <a:r>
@@ -11219,14 +11055,14 @@
       </p:sp>
       <p:pic>
         <p:nvPicPr>
-          <p:cNvPr id="12" name="Image 4" descr="ic-check.png">    </p:cNvPr>
+          <p:cNvPr id="12" name="Image 4" descr="ic-check.png"/>
           <p:cNvPicPr>
             <a:picLocks noChangeAspect="1"/>
           </p:cNvPicPr>
           <p:nvPr/>
         </p:nvPicPr>
         <p:blipFill>
-          <a:blip r:embed="rId5"/>
+          <a:blip r:embed="rId7"/>
           <a:stretch>
             <a:fillRect/>
           </a:stretch>
@@ -11262,7 +11098,7 @@
           <a:bodyPr wrap="square" rtlCol="0" anchor="ctr"/>
           <a:lstStyle/>
           <a:p>
-            <a:pPr algn="r" indent="0" marL="0">
+            <a:pPr marL="0" indent="0" algn="r">
               <a:buNone/>
             </a:pPr>
             <a:r>
@@ -11581,4 +11417,319 @@
     </a:ext>
   </a:extLst>
 </a:theme>
+</file>
+
+<file path=ppt/theme/theme2.xml><?xml version="1.0" encoding="utf-8"?>
+<a:theme xmlns:a="http://schemas.openxmlformats.org/drawingml/2006/main" name="Office Theme">
+  <a:themeElements>
+    <a:clrScheme name="Office">
+      <a:dk1>
+        <a:sysClr val="windowText" lastClr="000000"/>
+      </a:dk1>
+      <a:lt1>
+        <a:sysClr val="window" lastClr="FFFFFF"/>
+      </a:lt1>
+      <a:dk2>
+        <a:srgbClr val="0E2841"/>
+      </a:dk2>
+      <a:lt2>
+        <a:srgbClr val="E8E8E8"/>
+      </a:lt2>
+      <a:accent1>
+        <a:srgbClr val="156082"/>
+      </a:accent1>
+      <a:accent2>
+        <a:srgbClr val="E97132"/>
+      </a:accent2>
+      <a:accent3>
+        <a:srgbClr val="196B24"/>
+      </a:accent3>
+      <a:accent4>
+        <a:srgbClr val="0F9ED5"/>
+      </a:accent4>
+      <a:accent5>
+        <a:srgbClr val="A02B93"/>
+      </a:accent5>
+      <a:accent6>
+        <a:srgbClr val="4EA72E"/>
+      </a:accent6>
+      <a:hlink>
+        <a:srgbClr val="467886"/>
+      </a:hlink>
+      <a:folHlink>
+        <a:srgbClr val="96607D"/>
+      </a:folHlink>
+    </a:clrScheme>
+    <a:fontScheme name="Office">
+      <a:majorFont>
+        <a:latin typeface="Aptos Display" panose="02110004020202020204"/>
+        <a:ea typeface=""/>
+        <a:cs typeface=""/>
+        <a:font script="Jpan" typeface="游ゴシック Light"/>
+        <a:font script="Hang" typeface="맑은 고딕"/>
+        <a:font script="Hans" typeface="等线 Light"/>
+        <a:font script="Hant" typeface="新細明體"/>
+        <a:font script="Arab" typeface="Times New Roman"/>
+        <a:font script="Hebr" typeface="Times New Roman"/>
+        <a:font script="Thai" typeface="Angsana New"/>
+        <a:font script="Ethi" typeface="Nyala"/>
+        <a:font script="Beng" typeface="Vrinda"/>
+        <a:font script="Gujr" typeface="Shruti"/>
+        <a:font script="Khmr" typeface="MoolBoran"/>
+        <a:font script="Knda" typeface="Tunga"/>
+        <a:font script="Guru" typeface="Raavi"/>
+        <a:font script="Cans" typeface="Euphemia"/>
+        <a:font script="Cher" typeface="Plantagenet Cherokee"/>
+        <a:font script="Yiii" typeface="Microsoft Yi Baiti"/>
+        <a:font script="Tibt" typeface="Microsoft Himalaya"/>
+        <a:font script="Thaa" typeface="MV Boli"/>
+        <a:font script="Deva" typeface="Mangal"/>
+        <a:font script="Telu" typeface="Gautami"/>
+        <a:font script="Taml" typeface="Latha"/>
+        <a:font script="Syrc" typeface="Estrangelo Edessa"/>
+        <a:font script="Orya" typeface="Kalinga"/>
+        <a:font script="Mlym" typeface="Kartika"/>
+        <a:font script="Laoo" typeface="DokChampa"/>
+        <a:font script="Sinh" typeface="Iskoola Pota"/>
+        <a:font script="Mong" typeface="Mongolian Baiti"/>
+        <a:font script="Viet" typeface="Times New Roman"/>
+        <a:font script="Uigh" typeface="Microsoft Uighur"/>
+        <a:font script="Geor" typeface="Sylfaen"/>
+        <a:font script="Armn" typeface="Arial"/>
+        <a:font script="Bugi" typeface="Leelawadee UI"/>
+        <a:font script="Bopo" typeface="Microsoft JhengHei"/>
+        <a:font script="Java" typeface="Javanese Text"/>
+        <a:font script="Lisu" typeface="Segoe UI"/>
+        <a:font script="Mymr" typeface="Myanmar Text"/>
+        <a:font script="Nkoo" typeface="Ebrima"/>
+        <a:font script="Olck" typeface="Nirmala UI"/>
+        <a:font script="Osma" typeface="Ebrima"/>
+        <a:font script="Phag" typeface="Phagspa"/>
+        <a:font script="Syrn" typeface="Estrangelo Edessa"/>
+        <a:font script="Syrj" typeface="Estrangelo Edessa"/>
+        <a:font script="Syre" typeface="Estrangelo Edessa"/>
+        <a:font script="Sora" typeface="Nirmala UI"/>
+        <a:font script="Tale" typeface="Microsoft Tai Le"/>
+        <a:font script="Talu" typeface="Microsoft New Tai Lue"/>
+        <a:font script="Tfng" typeface="Ebrima"/>
+      </a:majorFont>
+      <a:minorFont>
+        <a:latin typeface="Aptos" panose="02110004020202020204"/>
+        <a:ea typeface=""/>
+        <a:cs typeface=""/>
+        <a:font script="Jpan" typeface="游ゴシック"/>
+        <a:font script="Hang" typeface="맑은 고딕"/>
+        <a:font script="Hans" typeface="等线"/>
+        <a:font script="Hant" typeface="新細明體"/>
+        <a:font script="Arab" typeface="Arial"/>
+        <a:font script="Hebr" typeface="Arial"/>
+        <a:font script="Thai" typeface="Cordia New"/>
+        <a:font script="Ethi" typeface="Nyala"/>
+        <a:font script="Beng" typeface="Vrinda"/>
+        <a:font script="Gujr" typeface="Shruti"/>
+        <a:font script="Khmr" typeface="DaunPenh"/>
+        <a:font script="Knda" typeface="Tunga"/>
+        <a:font script="Guru" typeface="Raavi"/>
+        <a:font script="Cans" typeface="Euphemia"/>
+        <a:font script="Cher" typeface="Plantagenet Cherokee"/>
+        <a:font script="Yiii" typeface="Microsoft Yi Baiti"/>
+        <a:font script="Tibt" typeface="Microsoft Himalaya"/>
+        <a:font script="Thaa" typeface="MV Boli"/>
+        <a:font script="Deva" typeface="Mangal"/>
+        <a:font script="Telu" typeface="Gautami"/>
+        <a:font script="Taml" typeface="Latha"/>
+        <a:font script="Syrc" typeface="Estrangelo Edessa"/>
+        <a:font script="Orya" typeface="Kalinga"/>
+        <a:font script="Mlym" typeface="Kartika"/>
+        <a:font script="Laoo" typeface="DokChampa"/>
+        <a:font script="Sinh" typeface="Iskoola Pota"/>
+        <a:font script="Mong" typeface="Mongolian Baiti"/>
+        <a:font script="Viet" typeface="Arial"/>
+        <a:font script="Uigh" typeface="Microsoft Uighur"/>
+        <a:font script="Geor" typeface="Sylfaen"/>
+        <a:font script="Armn" typeface="Arial"/>
+        <a:font script="Bugi" typeface="Leelawadee UI"/>
+        <a:font script="Bopo" typeface="Microsoft JhengHei"/>
+        <a:font script="Java" typeface="Javanese Text"/>
+        <a:font script="Lisu" typeface="Segoe UI"/>
+        <a:font script="Mymr" typeface="Myanmar Text"/>
+        <a:font script="Nkoo" typeface="Ebrima"/>
+        <a:font script="Olck" typeface="Nirmala UI"/>
+        <a:font script="Osma" typeface="Ebrima"/>
+        <a:font script="Phag" typeface="Phagspa"/>
+        <a:font script="Syrn" typeface="Estrangelo Edessa"/>
+        <a:font script="Syrj" typeface="Estrangelo Edessa"/>
+        <a:font script="Syre" typeface="Estrangelo Edessa"/>
+        <a:font script="Sora" typeface="Nirmala UI"/>
+        <a:font script="Tale" typeface="Microsoft Tai Le"/>
+        <a:font script="Talu" typeface="Microsoft New Tai Lue"/>
+        <a:font script="Tfng" typeface="Ebrima"/>
+      </a:minorFont>
+    </a:fontScheme>
+    <a:fmtScheme name="Office">
+      <a:fillStyleLst>
+        <a:solidFill>
+          <a:schemeClr val="phClr"/>
+        </a:solidFill>
+        <a:gradFill rotWithShape="1">
+          <a:gsLst>
+            <a:gs pos="0">
+              <a:schemeClr val="phClr">
+                <a:lumMod val="110000"/>
+                <a:satMod val="105000"/>
+                <a:tint val="67000"/>
+              </a:schemeClr>
+            </a:gs>
+            <a:gs pos="50000">
+              <a:schemeClr val="phClr">
+                <a:lumMod val="105000"/>
+                <a:satMod val="103000"/>
+                <a:tint val="73000"/>
+              </a:schemeClr>
+            </a:gs>
+            <a:gs pos="100000">
+              <a:schemeClr val="phClr">
+                <a:lumMod val="105000"/>
+                <a:satMod val="109000"/>
+                <a:tint val="81000"/>
+              </a:schemeClr>
+            </a:gs>
+          </a:gsLst>
+          <a:lin ang="5400000" scaled="0"/>
+        </a:gradFill>
+        <a:gradFill rotWithShape="1">
+          <a:gsLst>
+            <a:gs pos="0">
+              <a:schemeClr val="phClr">
+                <a:satMod val="103000"/>
+                <a:lumMod val="102000"/>
+                <a:tint val="94000"/>
+              </a:schemeClr>
+            </a:gs>
+            <a:gs pos="50000">
+              <a:schemeClr val="phClr">
+                <a:satMod val="110000"/>
+                <a:lumMod val="100000"/>
+                <a:shade val="100000"/>
+              </a:schemeClr>
+            </a:gs>
+            <a:gs pos="100000">
+              <a:schemeClr val="phClr">
+                <a:lumMod val="99000"/>
+                <a:satMod val="120000"/>
+                <a:shade val="78000"/>
+              </a:schemeClr>
+            </a:gs>
+          </a:gsLst>
+          <a:lin ang="5400000" scaled="0"/>
+        </a:gradFill>
+      </a:fillStyleLst>
+      <a:lnStyleLst>
+        <a:ln w="12700" cap="flat" cmpd="sng" algn="ctr">
+          <a:solidFill>
+            <a:schemeClr val="phClr"/>
+          </a:solidFill>
+          <a:prstDash val="solid"/>
+          <a:miter lim="800000"/>
+        </a:ln>
+        <a:ln w="19050" cap="flat" cmpd="sng" algn="ctr">
+          <a:solidFill>
+            <a:schemeClr val="phClr"/>
+          </a:solidFill>
+          <a:prstDash val="solid"/>
+          <a:miter lim="800000"/>
+        </a:ln>
+        <a:ln w="25400" cap="flat" cmpd="sng" algn="ctr">
+          <a:solidFill>
+            <a:schemeClr val="phClr"/>
+          </a:solidFill>
+          <a:prstDash val="solid"/>
+          <a:miter lim="800000"/>
+        </a:ln>
+      </a:lnStyleLst>
+      <a:effectStyleLst>
+        <a:effectStyle>
+          <a:effectLst/>
+        </a:effectStyle>
+        <a:effectStyle>
+          <a:effectLst/>
+        </a:effectStyle>
+        <a:effectStyle>
+          <a:effectLst>
+            <a:outerShdw blurRad="57150" dist="19050" dir="5400000" algn="ctr" rotWithShape="0">
+              <a:srgbClr val="000000">
+                <a:alpha val="63000"/>
+              </a:srgbClr>
+            </a:outerShdw>
+          </a:effectLst>
+        </a:effectStyle>
+      </a:effectStyleLst>
+      <a:bgFillStyleLst>
+        <a:solidFill>
+          <a:schemeClr val="phClr"/>
+        </a:solidFill>
+        <a:solidFill>
+          <a:schemeClr val="phClr">
+            <a:tint val="95000"/>
+            <a:satMod val="170000"/>
+          </a:schemeClr>
+        </a:solidFill>
+        <a:gradFill rotWithShape="1">
+          <a:gsLst>
+            <a:gs pos="0">
+              <a:schemeClr val="phClr">
+                <a:tint val="93000"/>
+                <a:satMod val="150000"/>
+                <a:shade val="98000"/>
+                <a:lumMod val="102000"/>
+              </a:schemeClr>
+            </a:gs>
+            <a:gs pos="50000">
+              <a:schemeClr val="phClr">
+                <a:tint val="98000"/>
+                <a:satMod val="130000"/>
+                <a:shade val="90000"/>
+                <a:lumMod val="103000"/>
+              </a:schemeClr>
+            </a:gs>
+            <a:gs pos="100000">
+              <a:schemeClr val="phClr">
+                <a:shade val="63000"/>
+                <a:satMod val="120000"/>
+              </a:schemeClr>
+            </a:gs>
+          </a:gsLst>
+          <a:lin ang="5400000" scaled="0"/>
+        </a:gradFill>
+      </a:bgFillStyleLst>
+    </a:fmtScheme>
+  </a:themeElements>
+  <a:objectDefaults>
+    <a:lnDef>
+      <a:spPr/>
+      <a:bodyPr/>
+      <a:lstStyle/>
+      <a:style>
+        <a:lnRef idx="2">
+          <a:schemeClr val="accent1"/>
+        </a:lnRef>
+        <a:fillRef idx="0">
+          <a:schemeClr val="accent1"/>
+        </a:fillRef>
+        <a:effectRef idx="1">
+          <a:schemeClr val="accent1"/>
+        </a:effectRef>
+        <a:fontRef idx="minor">
+          <a:schemeClr val="tx1"/>
+        </a:fontRef>
+      </a:style>
+    </a:lnDef>
+  </a:objectDefaults>
+  <a:extraClrSchemeLst/>
+  <a:extLst>
+    <a:ext uri="{05A4C25C-085E-4340-85A3-A5531E510DB2}">
+      <thm15:themeFamily xmlns:thm15="http://schemas.microsoft.com/office/thememl/2012/main" name="Office Theme" id="{2E142A2C-CD16-42D6-873A-C26D2A0506FA}" vid="{1BDDFF52-6CD6-40A5-AB3C-68EB2F1E4D0A}"/>
+    </a:ext>
+  </a:extLst>
+</a:theme>
 </file>
</xml_diff>